<commit_message>
Complete step-by-step visual guides for Lab 05
</commit_message>
<xml_diff>
--- a/slides/LAB05_Cloud_Notes_Bukti_Live.pptx
+++ b/slides/LAB05_Cloud_Notes_Bukti_Live.pptx
@@ -22,6 +22,8 @@
     <p:sldId id="299" r:id="rId13"/>
     <p:sldId id="300" r:id="rId14"/>
     <p:sldId id="301" r:id="rId15"/>
+    <p:sldId id="302" r:id="rId21"/>
+    <p:sldId id="303" r:id="rId22"/>
   </p:sldIdLst>
   <p:sldSz cx="12192000" cy="6858000"/>
   <p:notesSz cx="6858000" cy="12192000"/>
@@ -5926,6 +5928,1318 @@
         <p14:creationId xmlns:p14="http://schemas.microsoft.com/office/powerpoint/2010/main" val="494078226"/>
       </p:ext>
     </p:extLst>
+  </p:cSld>
+  <p:clrMapOvr>
+    <a:masterClrMapping/>
+  </p:clrMapOvr>
+</p:sld>
+</file>
+
+<file path=ppt/slides/slide15.xml><?xml version="1.0" encoding="utf-8"?>
+<p:sld xmlns:a="http://schemas.openxmlformats.org/drawingml/2006/main" xmlns:p="http://schemas.openxmlformats.org/presentationml/2006/main" xmlns:r="http://schemas.openxmlformats.org/officeDocument/2006/relationships">
+  <p:cSld>
+    <p:spTree>
+      <p:nvGrpSpPr>
+        <p:cNvPr id="1" name=""/>
+        <p:cNvGrpSpPr/>
+        <p:nvPr/>
+      </p:nvGrpSpPr>
+      <p:grpSpPr/>
+      <p:sp>
+        <p:nvSpPr>
+          <p:cNvPr id="2" name="Text 0"/>
+          <p:cNvSpPr/>
+          <p:nvPr/>
+        </p:nvSpPr>
+        <p:spPr>
+          <a:xfrm>
+            <a:off x="457200" y="6492240"/>
+            <a:ext cx="7315200" cy="274320"/>
+          </a:xfrm>
+          <a:prstGeom prst="rect">
+            <a:avLst/>
+          </a:prstGeom>
+          <a:noFill/>
+          <a:ln/>
+        </p:spPr>
+        <p:txBody>
+          <a:bodyPr wrap="square" lIns="0" tIns="0" rIns="0" bIns="0" rtlCol="0" anchor="ctr"/>
+          <a:lstStyle/>
+          <a:p>
+            <a:pPr marL="0" indent="0" algn="l">
+              <a:buNone/>
+            </a:pPr>
+            <a:r>
+              <a:rPr lang="en-US" sz="900" dirty="0">
+                <a:solidFill>
+                  <a:srgbClr val="64748B"/>
+                </a:solidFill>
+                <a:latin typeface="Calibri" pitchFamily="34" charset="0"/>
+                <a:ea typeface="Calibri" pitchFamily="34" charset="-122"/>
+                <a:cs typeface="Calibri" pitchFamily="34" charset="-120"/>
+              </a:rPr>
+              <a:t>BINUS UNIVERSITY  |  Cloud Services  |  Praktikum 5</a:t>
+            </a:r>
+            <a:endParaRPr lang="en-US" sz="900" dirty="0"/>
+          </a:p>
+        </p:txBody>
+      </p:sp>
+      <p:sp>
+        <p:nvSpPr>
+          <p:cNvPr id="3" name="Text 1"/>
+          <p:cNvSpPr/>
+          <p:nvPr/>
+        </p:nvSpPr>
+        <p:spPr>
+          <a:xfrm>
+            <a:off x="11247120" y="6492240"/>
+            <a:ext cx="457200" cy="274320"/>
+          </a:xfrm>
+          <a:prstGeom prst="rect">
+            <a:avLst/>
+          </a:prstGeom>
+          <a:noFill/>
+          <a:ln/>
+        </p:spPr>
+        <p:txBody>
+          <a:bodyPr wrap="square" lIns="0" tIns="0" rIns="0" bIns="0" rtlCol="0" anchor="ctr"/>
+          <a:lstStyle/>
+          <a:p>
+            <a:pPr marL="0" indent="0" algn="r">
+              <a:buNone/>
+            </a:pPr>
+            <a:r>
+              <a:rPr lang="en-US" sz="900" b="1">
+                <a:solidFill>
+                  <a:srgbClr val="64748B"/>
+                </a:solidFill>
+                <a:latin typeface="Calibri" pitchFamily="34" charset="0"/>
+                <a:ea typeface="Calibri" pitchFamily="34" charset="-122"/>
+                <a:cs typeface="Calibri" pitchFamily="34" charset="-120"/>
+              </a:rPr>
+              <a:t>15</a:t>
+            </a:r>
+            <a:endParaRPr lang="en-US" sz="900" dirty="0"/>
+          </a:p>
+        </p:txBody>
+      </p:sp>
+      <p:sp>
+        <p:nvSpPr>
+          <p:cNvPr id="4" name="Shape 2"/>
+          <p:cNvSpPr/>
+          <p:nvPr/>
+        </p:nvSpPr>
+        <p:spPr>
+          <a:xfrm>
+            <a:off x="457200" y="6446520"/>
+            <a:ext cx="228600" cy="36576"/>
+          </a:xfrm>
+          <a:prstGeom prst="rect">
+            <a:avLst/>
+          </a:prstGeom>
+          <a:solidFill>
+            <a:srgbClr val="F37021"/>
+          </a:solidFill>
+          <a:ln w="12700">
+            <a:solidFill>
+              <a:srgbClr val="F37021"/>
+            </a:solidFill>
+            <a:prstDash val="solid"/>
+          </a:ln>
+        </p:spPr>
+      </p:sp>
+      <p:pic>
+        <p:nvPicPr>
+          <p:cNvPr id="5" name="Picture 4" descr="image.png"/>
+          <p:cNvPicPr>
+            <a:picLocks noChangeAspect="1"/>
+          </p:cNvPicPr>
+          <p:nvPr/>
+        </p:nvPicPr>
+        <p:blipFill>
+          <a:blip r:embed="rId2"/>
+          <a:stretch>
+            <a:fillRect/>
+          </a:stretch>
+        </p:blipFill>
+        <p:spPr>
+          <a:xfrm>
+            <a:off x="274320" y="164592"/>
+            <a:ext cx="914400" cy="603504"/>
+          </a:xfrm>
+          <a:prstGeom prst="rect">
+            <a:avLst/>
+          </a:prstGeom>
+        </p:spPr>
+      </p:pic>
+      <p:pic>
+        <p:nvPicPr>
+          <p:cNvPr id="6" name="Picture 5" descr="image.png"/>
+          <p:cNvPicPr>
+            <a:picLocks noChangeAspect="1"/>
+          </p:cNvPicPr>
+          <p:nvPr/>
+        </p:nvPicPr>
+        <p:blipFill>
+          <a:blip r:embed="rId3"/>
+          <a:stretch>
+            <a:fillRect/>
+          </a:stretch>
+        </p:blipFill>
+        <p:spPr>
+          <a:xfrm>
+            <a:off x="10881360" y="182880"/>
+            <a:ext cx="1005840" cy="512064"/>
+          </a:xfrm>
+          <a:prstGeom prst="rect">
+            <a:avLst/>
+          </a:prstGeom>
+        </p:spPr>
+      </p:pic>
+      <p:sp>
+        <p:nvSpPr>
+          <p:cNvPr id="7" name="Shape 3"/>
+          <p:cNvSpPr/>
+          <p:nvPr/>
+        </p:nvSpPr>
+        <p:spPr>
+          <a:xfrm>
+            <a:off x="457200" y="868680"/>
+            <a:ext cx="11247120" cy="0"/>
+          </a:xfrm>
+          <a:prstGeom prst="line">
+            <a:avLst/>
+          </a:prstGeom>
+          <a:noFill/>
+          <a:ln w="12700">
+            <a:solidFill>
+              <a:srgbClr val="E2E8F0"/>
+            </a:solidFill>
+            <a:prstDash val="solid"/>
+          </a:ln>
+        </p:spPr>
+      </p:sp>
+      <p:sp>
+        <p:nvSpPr>
+          <p:cNvPr id="8" name="Text 4"/>
+          <p:cNvSpPr/>
+          <p:nvPr/>
+        </p:nvSpPr>
+        <p:spPr>
+          <a:xfrm>
+            <a:off x="2011680" y="182880"/>
+            <a:ext cx="8138160" cy="502920"/>
+          </a:xfrm>
+          <a:prstGeom prst="rect">
+            <a:avLst/>
+          </a:prstGeom>
+          <a:noFill/>
+          <a:ln/>
+        </p:spPr>
+        <p:txBody>
+          <a:bodyPr wrap="square" lIns="0" tIns="0" rIns="0" bIns="0" rtlCol="0" anchor="ctr"/>
+          <a:lstStyle/>
+          <a:p>
+            <a:pPr marL="0" indent="0" algn="ctr">
+              <a:buNone/>
+            </a:pPr>
+            <a:r>
+              <a:rPr lang="nl-NL" sz="2200" b="1">
+                <a:solidFill>
+                  <a:srgbClr val="1976D2"/>
+                </a:solidFill>
+                <a:latin typeface="Calibri" pitchFamily="34" charset="0"/>
+                <a:ea typeface="Calibri" pitchFamily="34" charset="-122"/>
+                <a:cs typeface="Calibri" pitchFamily="34" charset="-120"/>
+              </a:rPr>
+              <a:t>Bukti awal | Dockerfile dan Engine</a:t>
+            </a:r>
+            <a:endParaRPr lang="en-US" sz="2200" dirty="0"/>
+          </a:p>
+        </p:txBody>
+      </p:sp>
+      <p:sp>
+        <p:nvSpPr>
+          <p:cNvPr id="9" name="Text 5"/>
+          <p:cNvSpPr/>
+          <p:nvPr/>
+        </p:nvSpPr>
+        <p:spPr>
+          <a:xfrm>
+            <a:off x="457200" y="960120"/>
+            <a:ext cx="11247120" cy="320040"/>
+          </a:xfrm>
+          <a:prstGeom prst="rect">
+            <a:avLst/>
+          </a:prstGeom>
+          <a:noFill/>
+          <a:ln/>
+        </p:spPr>
+        <p:txBody>
+          <a:bodyPr wrap="square" lIns="0" tIns="0" rIns="0" bIns="0" rtlCol="0" anchor="ctr"/>
+          <a:lstStyle/>
+          <a:p>
+            <a:pPr marL="0" indent="0" algn="ctr">
+              <a:buNone/>
+            </a:pPr>
+            <a:r>
+              <a:rPr lang="en-US" sz="1200" i="1">
+                <a:solidFill>
+                  <a:srgbClr val="64748B"/>
+                </a:solidFill>
+                <a:latin typeface="Calibri" pitchFamily="34" charset="0"/>
+                <a:ea typeface="Calibri" pitchFamily="34" charset="-122"/>
+                <a:cs typeface="Calibri" pitchFamily="34" charset="-120"/>
+              </a:rPr>
+              <a:t>docker version; Select-String Dockerfile  |  render output aktual</a:t>
+            </a:r>
+            <a:endParaRPr lang="en-US" sz="1200" dirty="0"/>
+          </a:p>
+        </p:txBody>
+      </p:sp>
+      <p:sp>
+        <p:nvSpPr>
+          <p:cNvPr id="27" name="Rectangle 26">
+            <a:extLst>
+              <a:ext uri="{FF2B5EF4-FFF2-40B4-BE49-F238E27FC236}">
+                <a16:creationId xmlns:a16="http://schemas.microsoft.com/office/drawing/2014/main" id="{CA2C3FC3-2268-3632-60A5-8F36FCCD90BB}"/>
+              </a:ext>
+            </a:extLst>
+          </p:cNvPr>
+          <p:cNvSpPr/>
+          <p:nvPr/>
+        </p:nvSpPr>
+        <p:spPr>
+          <a:xfrm>
+            <a:off x="457200" y="1409700"/>
+            <a:ext cx="11252200" cy="3886200"/>
+          </a:xfrm>
+          <a:prstGeom prst="rect">
+            <a:avLst/>
+          </a:prstGeom>
+          <a:solidFill>
+            <a:srgbClr val="F6F8FC"/>
+          </a:solidFill>
+          <a:ln>
+            <a:solidFill>
+              <a:srgbClr val="D3DEEE"/>
+            </a:solidFill>
+          </a:ln>
+        </p:spPr>
+        <p:style>
+          <a:lnRef idx="2">
+            <a:schemeClr val="accent1">
+              <a:shade val="15000"/>
+            </a:schemeClr>
+          </a:lnRef>
+          <a:fillRef idx="1">
+            <a:schemeClr val="accent1"/>
+          </a:fillRef>
+          <a:effectRef idx="0">
+            <a:schemeClr val="accent1"/>
+          </a:effectRef>
+          <a:fontRef idx="minor">
+            <a:schemeClr val="lt1"/>
+          </a:fontRef>
+        </p:style>
+        <p:txBody>
+          <a:bodyPr rtlCol="0" anchor="ctr"/>
+          <a:lstStyle/>
+          <a:p>
+            <a:pPr algn="ctr"/>
+            <a:endParaRPr lang="en-US"/>
+          </a:p>
+        </p:txBody>
+      </p:sp>
+      <p:sp>
+        <p:nvSpPr>
+          <p:cNvPr id="30" name="Rectangle 29">
+            <a:extLst>
+              <a:ext uri="{FF2B5EF4-FFF2-40B4-BE49-F238E27FC236}">
+                <a16:creationId xmlns:a16="http://schemas.microsoft.com/office/drawing/2014/main" id="{784C38AF-D50D-3EDB-2A20-35E588144107}"/>
+              </a:ext>
+            </a:extLst>
+          </p:cNvPr>
+          <p:cNvSpPr/>
+          <p:nvPr/>
+        </p:nvSpPr>
+        <p:spPr>
+          <a:xfrm>
+            <a:off x="457200" y="5397500"/>
+            <a:ext cx="11252200" cy="787400"/>
+          </a:xfrm>
+          <a:prstGeom prst="rect">
+            <a:avLst/>
+          </a:prstGeom>
+          <a:solidFill>
+            <a:srgbClr val="002777"/>
+          </a:solidFill>
+          <a:ln w="12700" cap="flat" cmpd="sng" algn="ctr">
+            <a:noFill/>
+            <a:prstDash val="solid"/>
+            <a:miter lim="800000"/>
+          </a:ln>
+          <a:effectLst/>
+          <a:extLst>
+            <a:ext uri="{91240B29-F687-4F45-9708-019B960494DF}">
+              <a14:hiddenLine xmlns:a14="http://schemas.microsoft.com/office/drawing/2010/main" w="12700" cap="flat" cmpd="sng" algn="ctr">
+                <a:solidFill>
+                  <a:schemeClr val="accent1">
+                    <a:shade val="15000"/>
+                  </a:schemeClr>
+                </a:solidFill>
+                <a:prstDash val="solid"/>
+                <a:miter lim="800000"/>
+              </a14:hiddenLine>
+            </a:ext>
+          </a:extLst>
+        </p:spPr>
+        <p:style>
+          <a:lnRef idx="2">
+            <a:schemeClr val="accent1">
+              <a:shade val="15000"/>
+            </a:schemeClr>
+          </a:lnRef>
+          <a:fillRef idx="1">
+            <a:schemeClr val="accent1"/>
+          </a:fillRef>
+          <a:effectRef idx="0">
+            <a:schemeClr val="accent1"/>
+          </a:effectRef>
+          <a:fontRef idx="minor">
+            <a:schemeClr val="lt1"/>
+          </a:fontRef>
+        </p:style>
+        <p:txBody>
+          <a:bodyPr rtlCol="0" anchor="ctr"/>
+          <a:lstStyle/>
+          <a:p>
+            <a:pPr algn="ctr"/>
+            <a:endParaRPr lang="en-US"/>
+          </a:p>
+        </p:txBody>
+      </p:sp>
+      <p:sp>
+        <p:nvSpPr>
+          <p:cNvPr id="31" name="TextBox 30">
+            <a:extLst>
+              <a:ext uri="{FF2B5EF4-FFF2-40B4-BE49-F238E27FC236}">
+                <a16:creationId xmlns:a16="http://schemas.microsoft.com/office/drawing/2014/main" id="{78179848-0254-FC95-B234-981E0248F004}"/>
+              </a:ext>
+            </a:extLst>
+          </p:cNvPr>
+          <p:cNvSpPr txBox="1"/>
+          <p:nvPr/>
+        </p:nvSpPr>
+        <p:spPr>
+          <a:xfrm>
+            <a:off x="635000" y="5499100"/>
+            <a:ext cx="3429000" cy="276999"/>
+          </a:xfrm>
+          <a:prstGeom prst="rect">
+            <a:avLst/>
+          </a:prstGeom>
+          <a:noFill/>
+        </p:spPr>
+        <p:txBody>
+          <a:bodyPr vert="horz" wrap="square" lIns="0" tIns="0" rIns="0" bIns="0" rtlCol="0">
+            <a:noAutofit/>
+          </a:bodyPr>
+          <a:lstStyle/>
+          <a:p>
+            <a:r>
+              <a:rPr lang="en-US" sz="1050" b="1">
+                <a:solidFill>
+                  <a:srgbClr val="F37021"/>
+                </a:solidFill>
+                <a:latin typeface="Arial" panose="020B0604020202020204" pitchFamily="34" charset="0"/>
+              </a:rPr>
+              <a:t>BUILD</a:t>
+            </a:r>
+          </a:p>
+        </p:txBody>
+      </p:sp>
+      <p:sp>
+        <p:nvSpPr>
+          <p:cNvPr id="32" name="TextBox 31">
+            <a:extLst>
+              <a:ext uri="{FF2B5EF4-FFF2-40B4-BE49-F238E27FC236}">
+                <a16:creationId xmlns:a16="http://schemas.microsoft.com/office/drawing/2014/main" id="{9F041FD0-C768-9242-FF37-021E9D2B6BD9}"/>
+              </a:ext>
+            </a:extLst>
+          </p:cNvPr>
+          <p:cNvSpPr txBox="1"/>
+          <p:nvPr/>
+        </p:nvSpPr>
+        <p:spPr>
+          <a:xfrm>
+            <a:off x="635000" y="5727700"/>
+            <a:ext cx="3429000" cy="276999"/>
+          </a:xfrm>
+          <a:prstGeom prst="rect">
+            <a:avLst/>
+          </a:prstGeom>
+          <a:noFill/>
+        </p:spPr>
+        <p:txBody>
+          <a:bodyPr vert="horz" wrap="square" lIns="0" tIns="0" rIns="0" bIns="0" rtlCol="0">
+            <a:noAutofit/>
+          </a:bodyPr>
+          <a:lstStyle/>
+          <a:p>
+            <a:r>
+              <a:rPr lang="en-US" sz="1300">
+                <a:solidFill>
+                  <a:srgbClr val="FFFFFF"/>
+                </a:solidFill>
+                <a:latin typeface="Arial" panose="020B0604020202020204" pitchFamily="34" charset="0"/>
+              </a:rPr>
+              <a:t>FROM builder; RUN pip</a:t>
+            </a:r>
+          </a:p>
+        </p:txBody>
+      </p:sp>
+      <p:sp>
+        <p:nvSpPr>
+          <p:cNvPr id="33" name="TextBox 32">
+            <a:extLst>
+              <a:ext uri="{FF2B5EF4-FFF2-40B4-BE49-F238E27FC236}">
+                <a16:creationId xmlns:a16="http://schemas.microsoft.com/office/drawing/2014/main" id="{AF74B100-F150-BE1A-A13C-CBD2FCE7D19B}"/>
+              </a:ext>
+            </a:extLst>
+          </p:cNvPr>
+          <p:cNvSpPr txBox="1"/>
+          <p:nvPr/>
+        </p:nvSpPr>
+        <p:spPr>
+          <a:xfrm>
+            <a:off x="4318000" y="5499100"/>
+            <a:ext cx="3429000" cy="276999"/>
+          </a:xfrm>
+          <a:prstGeom prst="rect">
+            <a:avLst/>
+          </a:prstGeom>
+          <a:noFill/>
+        </p:spPr>
+        <p:txBody>
+          <a:bodyPr vert="horz" wrap="square" lIns="0" tIns="0" rIns="0" bIns="0" rtlCol="0">
+            <a:noAutofit/>
+          </a:bodyPr>
+          <a:lstStyle/>
+          <a:p>
+            <a:r>
+              <a:rPr lang="en-US" sz="1050" b="1">
+                <a:solidFill>
+                  <a:srgbClr val="F37021"/>
+                </a:solidFill>
+                <a:latin typeface="Arial" panose="020B0604020202020204" pitchFamily="34" charset="0"/>
+              </a:rPr>
+              <a:t>RUNTIME</a:t>
+            </a:r>
+          </a:p>
+        </p:txBody>
+      </p:sp>
+      <p:sp>
+        <p:nvSpPr>
+          <p:cNvPr id="34" name="TextBox 33">
+            <a:extLst>
+              <a:ext uri="{FF2B5EF4-FFF2-40B4-BE49-F238E27FC236}">
+                <a16:creationId xmlns:a16="http://schemas.microsoft.com/office/drawing/2014/main" id="{B864305D-94C1-CBA2-4912-2EC5B118054C}"/>
+              </a:ext>
+            </a:extLst>
+          </p:cNvPr>
+          <p:cNvSpPr txBox="1"/>
+          <p:nvPr/>
+        </p:nvSpPr>
+        <p:spPr>
+          <a:xfrm>
+            <a:off x="4318000" y="5727700"/>
+            <a:ext cx="3429000" cy="276999"/>
+          </a:xfrm>
+          <a:prstGeom prst="rect">
+            <a:avLst/>
+          </a:prstGeom>
+          <a:noFill/>
+        </p:spPr>
+        <p:txBody>
+          <a:bodyPr vert="horz" wrap="square" lIns="0" tIns="0" rIns="0" bIns="0" rtlCol="0">
+            <a:noAutofit/>
+          </a:bodyPr>
+          <a:lstStyle/>
+          <a:p>
+            <a:r>
+              <a:rPr lang="en-US" sz="1300">
+                <a:solidFill>
+                  <a:srgbClr val="FFFFFF"/>
+                </a:solidFill>
+                <a:latin typeface="Arial" panose="020B0604020202020204" pitchFamily="34" charset="0"/>
+              </a:rPr>
+              <a:t>USER appuser; CMD API</a:t>
+            </a:r>
+          </a:p>
+        </p:txBody>
+      </p:sp>
+      <p:sp>
+        <p:nvSpPr>
+          <p:cNvPr id="35" name="TextBox 34">
+            <a:extLst>
+              <a:ext uri="{FF2B5EF4-FFF2-40B4-BE49-F238E27FC236}">
+                <a16:creationId xmlns:a16="http://schemas.microsoft.com/office/drawing/2014/main" id="{7FEE0EF9-5060-12FC-A5E6-E5367599FF83}"/>
+              </a:ext>
+            </a:extLst>
+          </p:cNvPr>
+          <p:cNvSpPr txBox="1"/>
+          <p:nvPr/>
+        </p:nvSpPr>
+        <p:spPr>
+          <a:xfrm>
+            <a:off x="8001000" y="5499100"/>
+            <a:ext cx="3429000" cy="276999"/>
+          </a:xfrm>
+          <a:prstGeom prst="rect">
+            <a:avLst/>
+          </a:prstGeom>
+          <a:noFill/>
+        </p:spPr>
+        <p:txBody>
+          <a:bodyPr vert="horz" wrap="square" lIns="0" tIns="0" rIns="0" bIns="0" rtlCol="0">
+            <a:noAutofit/>
+          </a:bodyPr>
+          <a:lstStyle/>
+          <a:p>
+            <a:r>
+              <a:rPr lang="en-US" sz="1050" b="1">
+                <a:solidFill>
+                  <a:srgbClr val="F37021"/>
+                </a:solidFill>
+                <a:latin typeface="Arial" panose="020B0604020202020204" pitchFamily="34" charset="0"/>
+              </a:rPr>
+              <a:t>PORT</a:t>
+            </a:r>
+          </a:p>
+        </p:txBody>
+      </p:sp>
+      <p:sp>
+        <p:nvSpPr>
+          <p:cNvPr id="36" name="TextBox 35">
+            <a:extLst>
+              <a:ext uri="{FF2B5EF4-FFF2-40B4-BE49-F238E27FC236}">
+                <a16:creationId xmlns:a16="http://schemas.microsoft.com/office/drawing/2014/main" id="{B7FAF8FA-E512-3BA5-B85A-15159888CAEB}"/>
+              </a:ext>
+            </a:extLst>
+          </p:cNvPr>
+          <p:cNvSpPr txBox="1"/>
+          <p:nvPr/>
+        </p:nvSpPr>
+        <p:spPr>
+          <a:xfrm>
+            <a:off x="8001000" y="5727700"/>
+            <a:ext cx="3429000" cy="276999"/>
+          </a:xfrm>
+          <a:prstGeom prst="rect">
+            <a:avLst/>
+          </a:prstGeom>
+          <a:noFill/>
+        </p:spPr>
+        <p:txBody>
+          <a:bodyPr vert="horz" wrap="square" lIns="0" tIns="0" rIns="0" bIns="0" rtlCol="0">
+            <a:noAutofit/>
+          </a:bodyPr>
+          <a:lstStyle/>
+          <a:p>
+            <a:r>
+              <a:rPr lang="en-US" sz="1300">
+                <a:solidFill>
+                  <a:srgbClr val="FFFFFF"/>
+                </a:solidFill>
+                <a:latin typeface="Arial" panose="020B0604020202020204" pitchFamily="34" charset="0"/>
+              </a:rPr>
+              <a:t>Container mendengar 8000</a:t>
+            </a:r>
+          </a:p>
+        </p:txBody>
+      </p:sp>
+      <p:pic>
+        <p:nvPicPr>
+          <p:cNvPr id="37" name="Picture 36" descr="image.png"/>
+          <p:cNvPicPr>
+            <a:picLocks noChangeAspect="1"/>
+          </p:cNvPicPr>
+          <p:nvPr/>
+        </p:nvPicPr>
+        <p:blipFill>
+          <a:blip r:embed="rId4"/>
+          <a:stretch>
+            <a:fillRect/>
+          </a:stretch>
+        </p:blipFill>
+        <p:spPr>
+          <a:xfrm>
+            <a:off x="911350" y="1490898"/>
+            <a:ext cx="10343900" cy="3723804"/>
+          </a:xfrm>
+          <a:prstGeom prst="rect">
+            <a:avLst/>
+          </a:prstGeom>
+        </p:spPr>
+      </p:pic>
+    </p:spTree>
+  </p:cSld>
+  <p:clrMapOvr>
+    <a:masterClrMapping/>
+  </p:clrMapOvr>
+</p:sld>
+</file>
+
+<file path=ppt/slides/slide16.xml><?xml version="1.0" encoding="utf-8"?>
+<p:sld xmlns:a="http://schemas.openxmlformats.org/drawingml/2006/main" xmlns:p="http://schemas.openxmlformats.org/presentationml/2006/main" xmlns:r="http://schemas.openxmlformats.org/officeDocument/2006/relationships">
+  <p:cSld>
+    <p:spTree>
+      <p:nvGrpSpPr>
+        <p:cNvPr id="1" name=""/>
+        <p:cNvGrpSpPr/>
+        <p:nvPr/>
+      </p:nvGrpSpPr>
+      <p:grpSpPr/>
+      <p:sp>
+        <p:nvSpPr>
+          <p:cNvPr id="2" name="Text 0"/>
+          <p:cNvSpPr/>
+          <p:nvPr/>
+        </p:nvSpPr>
+        <p:spPr>
+          <a:xfrm>
+            <a:off x="457200" y="6492240"/>
+            <a:ext cx="7315200" cy="274320"/>
+          </a:xfrm>
+          <a:prstGeom prst="rect">
+            <a:avLst/>
+          </a:prstGeom>
+          <a:noFill/>
+          <a:ln/>
+        </p:spPr>
+        <p:txBody>
+          <a:bodyPr wrap="square" lIns="0" tIns="0" rIns="0" bIns="0" rtlCol="0" anchor="ctr"/>
+          <a:lstStyle/>
+          <a:p>
+            <a:pPr marL="0" indent="0" algn="l">
+              <a:buNone/>
+            </a:pPr>
+            <a:r>
+              <a:rPr lang="en-US" sz="900" dirty="0">
+                <a:solidFill>
+                  <a:srgbClr val="64748B"/>
+                </a:solidFill>
+                <a:latin typeface="Calibri" pitchFamily="34" charset="0"/>
+                <a:ea typeface="Calibri" pitchFamily="34" charset="-122"/>
+                <a:cs typeface="Calibri" pitchFamily="34" charset="-120"/>
+              </a:rPr>
+              <a:t>BINUS UNIVERSITY  |  Cloud Services  |  Praktikum 5</a:t>
+            </a:r>
+            <a:endParaRPr lang="en-US" sz="900" dirty="0"/>
+          </a:p>
+        </p:txBody>
+      </p:sp>
+      <p:sp>
+        <p:nvSpPr>
+          <p:cNvPr id="3" name="Text 1"/>
+          <p:cNvSpPr/>
+          <p:nvPr/>
+        </p:nvSpPr>
+        <p:spPr>
+          <a:xfrm>
+            <a:off x="11247120" y="6492240"/>
+            <a:ext cx="457200" cy="274320"/>
+          </a:xfrm>
+          <a:prstGeom prst="rect">
+            <a:avLst/>
+          </a:prstGeom>
+          <a:noFill/>
+          <a:ln/>
+        </p:spPr>
+        <p:txBody>
+          <a:bodyPr wrap="square" lIns="0" tIns="0" rIns="0" bIns="0" rtlCol="0" anchor="ctr"/>
+          <a:lstStyle/>
+          <a:p>
+            <a:pPr marL="0" indent="0" algn="r">
+              <a:buNone/>
+            </a:pPr>
+            <a:r>
+              <a:rPr lang="en-US" sz="900" b="1">
+                <a:solidFill>
+                  <a:srgbClr val="64748B"/>
+                </a:solidFill>
+                <a:latin typeface="Calibri" pitchFamily="34" charset="0"/>
+                <a:ea typeface="Calibri" pitchFamily="34" charset="-122"/>
+                <a:cs typeface="Calibri" pitchFamily="34" charset="-120"/>
+              </a:rPr>
+              <a:t>16</a:t>
+            </a:r>
+            <a:endParaRPr lang="en-US" sz="900" dirty="0"/>
+          </a:p>
+        </p:txBody>
+      </p:sp>
+      <p:sp>
+        <p:nvSpPr>
+          <p:cNvPr id="4" name="Shape 2"/>
+          <p:cNvSpPr/>
+          <p:nvPr/>
+        </p:nvSpPr>
+        <p:spPr>
+          <a:xfrm>
+            <a:off x="457200" y="6446520"/>
+            <a:ext cx="228600" cy="36576"/>
+          </a:xfrm>
+          <a:prstGeom prst="rect">
+            <a:avLst/>
+          </a:prstGeom>
+          <a:solidFill>
+            <a:srgbClr val="F37021"/>
+          </a:solidFill>
+          <a:ln w="12700">
+            <a:solidFill>
+              <a:srgbClr val="F37021"/>
+            </a:solidFill>
+            <a:prstDash val="solid"/>
+          </a:ln>
+        </p:spPr>
+      </p:sp>
+      <p:pic>
+        <p:nvPicPr>
+          <p:cNvPr id="5" name="Picture 4" descr="image.png"/>
+          <p:cNvPicPr>
+            <a:picLocks noChangeAspect="1"/>
+          </p:cNvPicPr>
+          <p:nvPr/>
+        </p:nvPicPr>
+        <p:blipFill>
+          <a:blip r:embed="rId2"/>
+          <a:stretch>
+            <a:fillRect/>
+          </a:stretch>
+        </p:blipFill>
+        <p:spPr>
+          <a:xfrm>
+            <a:off x="274320" y="164592"/>
+            <a:ext cx="914400" cy="603504"/>
+          </a:xfrm>
+          <a:prstGeom prst="rect">
+            <a:avLst/>
+          </a:prstGeom>
+        </p:spPr>
+      </p:pic>
+      <p:pic>
+        <p:nvPicPr>
+          <p:cNvPr id="6" name="Picture 5" descr="image.png"/>
+          <p:cNvPicPr>
+            <a:picLocks noChangeAspect="1"/>
+          </p:cNvPicPr>
+          <p:nvPr/>
+        </p:nvPicPr>
+        <p:blipFill>
+          <a:blip r:embed="rId3"/>
+          <a:stretch>
+            <a:fillRect/>
+          </a:stretch>
+        </p:blipFill>
+        <p:spPr>
+          <a:xfrm>
+            <a:off x="10881360" y="182880"/>
+            <a:ext cx="1005840" cy="512064"/>
+          </a:xfrm>
+          <a:prstGeom prst="rect">
+            <a:avLst/>
+          </a:prstGeom>
+        </p:spPr>
+      </p:pic>
+      <p:sp>
+        <p:nvSpPr>
+          <p:cNvPr id="7" name="Shape 3"/>
+          <p:cNvSpPr/>
+          <p:nvPr/>
+        </p:nvSpPr>
+        <p:spPr>
+          <a:xfrm>
+            <a:off x="457200" y="868680"/>
+            <a:ext cx="11247120" cy="0"/>
+          </a:xfrm>
+          <a:prstGeom prst="line">
+            <a:avLst/>
+          </a:prstGeom>
+          <a:noFill/>
+          <a:ln w="12700">
+            <a:solidFill>
+              <a:srgbClr val="E2E8F0"/>
+            </a:solidFill>
+            <a:prstDash val="solid"/>
+          </a:ln>
+        </p:spPr>
+      </p:sp>
+      <p:sp>
+        <p:nvSpPr>
+          <p:cNvPr id="8" name="Text 4"/>
+          <p:cNvSpPr/>
+          <p:nvPr/>
+        </p:nvSpPr>
+        <p:spPr>
+          <a:xfrm>
+            <a:off x="2011680" y="182880"/>
+            <a:ext cx="8138160" cy="502920"/>
+          </a:xfrm>
+          <a:prstGeom prst="rect">
+            <a:avLst/>
+          </a:prstGeom>
+          <a:noFill/>
+          <a:ln/>
+        </p:spPr>
+        <p:txBody>
+          <a:bodyPr wrap="square" lIns="0" tIns="0" rIns="0" bIns="0" rtlCol="0" anchor="ctr"/>
+          <a:lstStyle/>
+          <a:p>
+            <a:pPr marL="0" indent="0" algn="ctr">
+              <a:buNone/>
+            </a:pPr>
+            <a:r>
+              <a:rPr lang="nl-NL" sz="2200" b="1">
+                <a:solidFill>
+                  <a:srgbClr val="1976D2"/>
+                </a:solidFill>
+                <a:latin typeface="Calibri" pitchFamily="34" charset="0"/>
+                <a:ea typeface="Calibri" pitchFamily="34" charset="-122"/>
+                <a:cs typeface="Calibri" pitchFamily="34" charset="-120"/>
+              </a:rPr>
+              <a:t>Bukti Git | repo Lab 05 terbit</a:t>
+            </a:r>
+            <a:endParaRPr lang="en-US" sz="2200" dirty="0"/>
+          </a:p>
+        </p:txBody>
+      </p:sp>
+      <p:sp>
+        <p:nvSpPr>
+          <p:cNvPr id="9" name="Text 5"/>
+          <p:cNvSpPr/>
+          <p:nvPr/>
+        </p:nvSpPr>
+        <p:spPr>
+          <a:xfrm>
+            <a:off x="457200" y="960120"/>
+            <a:ext cx="11247120" cy="320040"/>
+          </a:xfrm>
+          <a:prstGeom prst="rect">
+            <a:avLst/>
+          </a:prstGeom>
+          <a:noFill/>
+          <a:ln/>
+        </p:spPr>
+        <p:txBody>
+          <a:bodyPr wrap="square" lIns="0" tIns="0" rIns="0" bIns="0" rtlCol="0" anchor="ctr"/>
+          <a:lstStyle/>
+          <a:p>
+            <a:pPr marL="0" indent="0" algn="ctr">
+              <a:buNone/>
+            </a:pPr>
+            <a:r>
+              <a:rPr lang="en-US" sz="1200" i="1">
+                <a:solidFill>
+                  <a:srgbClr val="64748B"/>
+                </a:solidFill>
+                <a:latin typeface="Calibri" pitchFamily="34" charset="0"/>
+                <a:ea typeface="Calibri" pitchFamily="34" charset="-122"/>
+                <a:cs typeface="Calibri" pitchFamily="34" charset="-120"/>
+              </a:rPr>
+              <a:t>remote, status, log, SHA main  |  contoh checkpoint pengajar</a:t>
+            </a:r>
+            <a:endParaRPr lang="en-US" sz="1200" dirty="0"/>
+          </a:p>
+        </p:txBody>
+      </p:sp>
+      <p:sp>
+        <p:nvSpPr>
+          <p:cNvPr id="27" name="Rectangle 26">
+            <a:extLst>
+              <a:ext uri="{FF2B5EF4-FFF2-40B4-BE49-F238E27FC236}">
+                <a16:creationId xmlns:a16="http://schemas.microsoft.com/office/drawing/2014/main" id="{CA2C3FC3-2268-3632-60A5-8F36FCCD90BB}"/>
+              </a:ext>
+            </a:extLst>
+          </p:cNvPr>
+          <p:cNvSpPr/>
+          <p:nvPr/>
+        </p:nvSpPr>
+        <p:spPr>
+          <a:xfrm>
+            <a:off x="457200" y="1409700"/>
+            <a:ext cx="11252200" cy="3886200"/>
+          </a:xfrm>
+          <a:prstGeom prst="rect">
+            <a:avLst/>
+          </a:prstGeom>
+          <a:solidFill>
+            <a:srgbClr val="F6F8FC"/>
+          </a:solidFill>
+          <a:ln>
+            <a:solidFill>
+              <a:srgbClr val="D3DEEE"/>
+            </a:solidFill>
+          </a:ln>
+        </p:spPr>
+        <p:style>
+          <a:lnRef idx="2">
+            <a:schemeClr val="accent1">
+              <a:shade val="15000"/>
+            </a:schemeClr>
+          </a:lnRef>
+          <a:fillRef idx="1">
+            <a:schemeClr val="accent1"/>
+          </a:fillRef>
+          <a:effectRef idx="0">
+            <a:schemeClr val="accent1"/>
+          </a:effectRef>
+          <a:fontRef idx="minor">
+            <a:schemeClr val="lt1"/>
+          </a:fontRef>
+        </p:style>
+        <p:txBody>
+          <a:bodyPr rtlCol="0" anchor="ctr"/>
+          <a:lstStyle/>
+          <a:p>
+            <a:pPr algn="ctr"/>
+            <a:endParaRPr lang="en-US"/>
+          </a:p>
+        </p:txBody>
+      </p:sp>
+      <p:sp>
+        <p:nvSpPr>
+          <p:cNvPr id="30" name="Rectangle 29">
+            <a:extLst>
+              <a:ext uri="{FF2B5EF4-FFF2-40B4-BE49-F238E27FC236}">
+                <a16:creationId xmlns:a16="http://schemas.microsoft.com/office/drawing/2014/main" id="{784C38AF-D50D-3EDB-2A20-35E588144107}"/>
+              </a:ext>
+            </a:extLst>
+          </p:cNvPr>
+          <p:cNvSpPr/>
+          <p:nvPr/>
+        </p:nvSpPr>
+        <p:spPr>
+          <a:xfrm>
+            <a:off x="457200" y="5397500"/>
+            <a:ext cx="11252200" cy="787400"/>
+          </a:xfrm>
+          <a:prstGeom prst="rect">
+            <a:avLst/>
+          </a:prstGeom>
+          <a:solidFill>
+            <a:srgbClr val="002777"/>
+          </a:solidFill>
+          <a:ln w="12700" cap="flat" cmpd="sng" algn="ctr">
+            <a:noFill/>
+            <a:prstDash val="solid"/>
+            <a:miter lim="800000"/>
+          </a:ln>
+          <a:effectLst/>
+          <a:extLst>
+            <a:ext uri="{91240B29-F687-4F45-9708-019B960494DF}">
+              <a14:hiddenLine xmlns:a14="http://schemas.microsoft.com/office/drawing/2010/main" w="12700" cap="flat" cmpd="sng" algn="ctr">
+                <a:solidFill>
+                  <a:schemeClr val="accent1">
+                    <a:shade val="15000"/>
+                  </a:schemeClr>
+                </a:solidFill>
+                <a:prstDash val="solid"/>
+                <a:miter lim="800000"/>
+              </a14:hiddenLine>
+            </a:ext>
+          </a:extLst>
+        </p:spPr>
+        <p:style>
+          <a:lnRef idx="2">
+            <a:schemeClr val="accent1">
+              <a:shade val="15000"/>
+            </a:schemeClr>
+          </a:lnRef>
+          <a:fillRef idx="1">
+            <a:schemeClr val="accent1"/>
+          </a:fillRef>
+          <a:effectRef idx="0">
+            <a:schemeClr val="accent1"/>
+          </a:effectRef>
+          <a:fontRef idx="minor">
+            <a:schemeClr val="lt1"/>
+          </a:fontRef>
+        </p:style>
+        <p:txBody>
+          <a:bodyPr rtlCol="0" anchor="ctr"/>
+          <a:lstStyle/>
+          <a:p>
+            <a:pPr algn="ctr"/>
+            <a:endParaRPr lang="en-US"/>
+          </a:p>
+        </p:txBody>
+      </p:sp>
+      <p:sp>
+        <p:nvSpPr>
+          <p:cNvPr id="31" name="TextBox 30">
+            <a:extLst>
+              <a:ext uri="{FF2B5EF4-FFF2-40B4-BE49-F238E27FC236}">
+                <a16:creationId xmlns:a16="http://schemas.microsoft.com/office/drawing/2014/main" id="{78179848-0254-FC95-B234-981E0248F004}"/>
+              </a:ext>
+            </a:extLst>
+          </p:cNvPr>
+          <p:cNvSpPr txBox="1"/>
+          <p:nvPr/>
+        </p:nvSpPr>
+        <p:spPr>
+          <a:xfrm>
+            <a:off x="635000" y="5499100"/>
+            <a:ext cx="3429000" cy="276999"/>
+          </a:xfrm>
+          <a:prstGeom prst="rect">
+            <a:avLst/>
+          </a:prstGeom>
+          <a:noFill/>
+        </p:spPr>
+        <p:txBody>
+          <a:bodyPr vert="horz" wrap="square" lIns="0" tIns="0" rIns="0" bIns="0" rtlCol="0">
+            <a:noAutofit/>
+          </a:bodyPr>
+          <a:lstStyle/>
+          <a:p>
+            <a:r>
+              <a:rPr lang="en-US" sz="1050" b="1">
+                <a:solidFill>
+                  <a:srgbClr val="F37021"/>
+                </a:solidFill>
+                <a:latin typeface="Arial" panose="020B0604020202020204" pitchFamily="34" charset="0"/>
+              </a:rPr>
+              <a:t>TUJUAN</a:t>
+            </a:r>
+          </a:p>
+        </p:txBody>
+      </p:sp>
+      <p:sp>
+        <p:nvSpPr>
+          <p:cNvPr id="32" name="TextBox 31">
+            <a:extLst>
+              <a:ext uri="{FF2B5EF4-FFF2-40B4-BE49-F238E27FC236}">
+                <a16:creationId xmlns:a16="http://schemas.microsoft.com/office/drawing/2014/main" id="{9F041FD0-C768-9242-FF37-021E9D2B6BD9}"/>
+              </a:ext>
+            </a:extLst>
+          </p:cNvPr>
+          <p:cNvSpPr txBox="1"/>
+          <p:nvPr/>
+        </p:nvSpPr>
+        <p:spPr>
+          <a:xfrm>
+            <a:off x="635000" y="5727700"/>
+            <a:ext cx="3429000" cy="276999"/>
+          </a:xfrm>
+          <a:prstGeom prst="rect">
+            <a:avLst/>
+          </a:prstGeom>
+          <a:noFill/>
+        </p:spPr>
+        <p:txBody>
+          <a:bodyPr vert="horz" wrap="square" lIns="0" tIns="0" rIns="0" bIns="0" rtlCol="0">
+            <a:noAutofit/>
+          </a:bodyPr>
+          <a:lstStyle/>
+          <a:p>
+            <a:r>
+              <a:rPr lang="en-US" sz="1300">
+                <a:solidFill>
+                  <a:srgbClr val="FFFFFF"/>
+                </a:solidFill>
+                <a:latin typeface="Arial" panose="020B0604020202020204" pitchFamily="34" charset="0"/>
+              </a:rPr>
+              <a:t>origin = meet5CloudService</a:t>
+            </a:r>
+          </a:p>
+        </p:txBody>
+      </p:sp>
+      <p:sp>
+        <p:nvSpPr>
+          <p:cNvPr id="33" name="TextBox 32">
+            <a:extLst>
+              <a:ext uri="{FF2B5EF4-FFF2-40B4-BE49-F238E27FC236}">
+                <a16:creationId xmlns:a16="http://schemas.microsoft.com/office/drawing/2014/main" id="{AF74B100-F150-BE1A-A13C-CBD2FCE7D19B}"/>
+              </a:ext>
+            </a:extLst>
+          </p:cNvPr>
+          <p:cNvSpPr txBox="1"/>
+          <p:nvPr/>
+        </p:nvSpPr>
+        <p:spPr>
+          <a:xfrm>
+            <a:off x="4318000" y="5499100"/>
+            <a:ext cx="3429000" cy="276999"/>
+          </a:xfrm>
+          <a:prstGeom prst="rect">
+            <a:avLst/>
+          </a:prstGeom>
+          <a:noFill/>
+        </p:spPr>
+        <p:txBody>
+          <a:bodyPr vert="horz" wrap="square" lIns="0" tIns="0" rIns="0" bIns="0" rtlCol="0">
+            <a:noAutofit/>
+          </a:bodyPr>
+          <a:lstStyle/>
+          <a:p>
+            <a:r>
+              <a:rPr lang="en-US" sz="1050" b="1">
+                <a:solidFill>
+                  <a:srgbClr val="F37021"/>
+                </a:solidFill>
+                <a:latin typeface="Arial" panose="020B0604020202020204" pitchFamily="34" charset="0"/>
+              </a:rPr>
+              <a:t>HASIL PUSH</a:t>
+            </a:r>
+          </a:p>
+        </p:txBody>
+      </p:sp>
+      <p:sp>
+        <p:nvSpPr>
+          <p:cNvPr id="34" name="TextBox 33">
+            <a:extLst>
+              <a:ext uri="{FF2B5EF4-FFF2-40B4-BE49-F238E27FC236}">
+                <a16:creationId xmlns:a16="http://schemas.microsoft.com/office/drawing/2014/main" id="{B864305D-94C1-CBA2-4912-2EC5B118054C}"/>
+              </a:ext>
+            </a:extLst>
+          </p:cNvPr>
+          <p:cNvSpPr txBox="1"/>
+          <p:nvPr/>
+        </p:nvSpPr>
+        <p:spPr>
+          <a:xfrm>
+            <a:off x="4318000" y="5727700"/>
+            <a:ext cx="3429000" cy="276999"/>
+          </a:xfrm>
+          <a:prstGeom prst="rect">
+            <a:avLst/>
+          </a:prstGeom>
+          <a:noFill/>
+        </p:spPr>
+        <p:txBody>
+          <a:bodyPr vert="horz" wrap="square" lIns="0" tIns="0" rIns="0" bIns="0" rtlCol="0">
+            <a:noAutofit/>
+          </a:bodyPr>
+          <a:lstStyle/>
+          <a:p>
+            <a:r>
+              <a:rPr lang="en-US" sz="1300">
+                <a:solidFill>
+                  <a:srgbClr val="FFFFFF"/>
+                </a:solidFill>
+                <a:latin typeface="Arial" panose="020B0604020202020204" pitchFamily="34" charset="0"/>
+              </a:rPr>
+              <a:t>SHA lokal = remote saat uji</a:t>
+            </a:r>
+          </a:p>
+        </p:txBody>
+      </p:sp>
+      <p:sp>
+        <p:nvSpPr>
+          <p:cNvPr id="35" name="TextBox 34">
+            <a:extLst>
+              <a:ext uri="{FF2B5EF4-FFF2-40B4-BE49-F238E27FC236}">
+                <a16:creationId xmlns:a16="http://schemas.microsoft.com/office/drawing/2014/main" id="{7FEE0EF9-5060-12FC-A5E6-E5367599FF83}"/>
+              </a:ext>
+            </a:extLst>
+          </p:cNvPr>
+          <p:cNvSpPr txBox="1"/>
+          <p:nvPr/>
+        </p:nvSpPr>
+        <p:spPr>
+          <a:xfrm>
+            <a:off x="8001000" y="5499100"/>
+            <a:ext cx="3429000" cy="276999"/>
+          </a:xfrm>
+          <a:prstGeom prst="rect">
+            <a:avLst/>
+          </a:prstGeom>
+          <a:noFill/>
+        </p:spPr>
+        <p:txBody>
+          <a:bodyPr vert="horz" wrap="square" lIns="0" tIns="0" rIns="0" bIns="0" rtlCol="0">
+            <a:noAutofit/>
+          </a:bodyPr>
+          <a:lstStyle/>
+          <a:p>
+            <a:r>
+              <a:rPr lang="en-US" sz="1050" b="1">
+                <a:solidFill>
+                  <a:srgbClr val="F37021"/>
+                </a:solidFill>
+                <a:latin typeface="Arial" panose="020B0604020202020204" pitchFamily="34" charset="0"/>
+              </a:rPr>
+              <a:t>MAHASISWA</a:t>
+            </a:r>
+          </a:p>
+        </p:txBody>
+      </p:sp>
+      <p:sp>
+        <p:nvSpPr>
+          <p:cNvPr id="36" name="TextBox 35">
+            <a:extLst>
+              <a:ext uri="{FF2B5EF4-FFF2-40B4-BE49-F238E27FC236}">
+                <a16:creationId xmlns:a16="http://schemas.microsoft.com/office/drawing/2014/main" id="{B7FAF8FA-E512-3BA5-B85A-15159888CAEB}"/>
+              </a:ext>
+            </a:extLst>
+          </p:cNvPr>
+          <p:cNvSpPr txBox="1"/>
+          <p:nvPr/>
+        </p:nvSpPr>
+        <p:spPr>
+          <a:xfrm>
+            <a:off x="8001000" y="5727700"/>
+            <a:ext cx="3429000" cy="276999"/>
+          </a:xfrm>
+          <a:prstGeom prst="rect">
+            <a:avLst/>
+          </a:prstGeom>
+          <a:noFill/>
+        </p:spPr>
+        <p:txBody>
+          <a:bodyPr vert="horz" wrap="square" lIns="0" tIns="0" rIns="0" bIns="0" rtlCol="0">
+            <a:noAutofit/>
+          </a:bodyPr>
+          <a:lstStyle/>
+          <a:p>
+            <a:r>
+              <a:rPr lang="en-US" sz="1300">
+                <a:solidFill>
+                  <a:srgbClr val="FFFFFF"/>
+                </a:solidFill>
+                <a:latin typeface="Arial" panose="020B0604020202020204" pitchFamily="34" charset="0"/>
+              </a:rPr>
+              <a:t>Ulangi pada repo pribadi</a:t>
+            </a:r>
+          </a:p>
+        </p:txBody>
+      </p:sp>
+      <p:pic>
+        <p:nvPicPr>
+          <p:cNvPr id="37" name="Picture 36" descr="image.png"/>
+          <p:cNvPicPr>
+            <a:picLocks noChangeAspect="1"/>
+          </p:cNvPicPr>
+          <p:nvPr/>
+        </p:nvPicPr>
+        <p:blipFill>
+          <a:blip r:embed="rId4"/>
+          <a:stretch>
+            <a:fillRect/>
+          </a:stretch>
+        </p:blipFill>
+        <p:spPr>
+          <a:xfrm>
+            <a:off x="1146439" y="1490898"/>
+            <a:ext cx="9873722" cy="3723804"/>
+          </a:xfrm>
+          <a:prstGeom prst="rect">
+            <a:avLst/>
+          </a:prstGeom>
+        </p:spPr>
+      </p:pic>
+    </p:spTree>
   </p:cSld>
   <p:clrMapOvr>
     <a:masterClrMapping/>

</xml_diff>

<commit_message>
Align Lab 05 with group project and publish revised theory/practical slides
</commit_message>
<xml_diff>
--- a/slides/LAB05_Cloud_Notes_Bukti_Live.pptx
+++ b/slides/LAB05_Cloud_Notes_Bukti_Live.pptx
@@ -2,28 +2,28 @@
 <file path=ppt/presentation.xml><?xml version="1.0" encoding="utf-8"?>
 <p:presentation xmlns:p="http://schemas.openxmlformats.org/presentationml/2006/main">
   <p:sldMasterIdLst>
-    <p:sldMasterId xmlns:r="http://schemas.openxmlformats.org/officeDocument/2006/relationships" id="2147483648" r:id="R928870c0e35b4b59"/>
+    <p:sldMasterId xmlns:r="http://schemas.openxmlformats.org/officeDocument/2006/relationships" id="2147483648" r:id="R8f5c93b48d7a4d0d"/>
   </p:sldMasterIdLst>
   <p:notesMasterIdLst>
-    <p:notesMasterId xmlns:r="http://schemas.openxmlformats.org/officeDocument/2006/relationships" r:id="Ra77410b05e2a4cc2"/>
+    <p:notesMasterId xmlns:r="http://schemas.openxmlformats.org/officeDocument/2006/relationships" r:id="R338e71d774bb4de9"/>
   </p:notesMasterIdLst>
   <p:sldIdLst>
-    <p:sldId xmlns:r="http://schemas.openxmlformats.org/officeDocument/2006/relationships" id="256" r:id="Re88d014343ac4e59"/>
-    <p:sldId xmlns:r="http://schemas.openxmlformats.org/officeDocument/2006/relationships" id="257" r:id="R02d130fbc0104d52"/>
-    <p:sldId xmlns:r="http://schemas.openxmlformats.org/officeDocument/2006/relationships" id="258" r:id="R34f4b1d495e74154"/>
-    <p:sldId xmlns:r="http://schemas.openxmlformats.org/officeDocument/2006/relationships" id="259" r:id="Rdd0264a1c1a140c4"/>
-    <p:sldId xmlns:r="http://schemas.openxmlformats.org/officeDocument/2006/relationships" id="260" r:id="R15e3145ac80e4a59"/>
-    <p:sldId xmlns:r="http://schemas.openxmlformats.org/officeDocument/2006/relationships" id="261" r:id="R80310ab98bb64a86"/>
-    <p:sldId xmlns:r="http://schemas.openxmlformats.org/officeDocument/2006/relationships" id="262" r:id="R162f8bbc3da246a1"/>
-    <p:sldId xmlns:r="http://schemas.openxmlformats.org/officeDocument/2006/relationships" id="263" r:id="R8ed14a0fa9ef4e1b"/>
-    <p:sldId xmlns:r="http://schemas.openxmlformats.org/officeDocument/2006/relationships" id="264" r:id="R6bd44ef4defd4f42"/>
-    <p:sldId xmlns:r="http://schemas.openxmlformats.org/officeDocument/2006/relationships" id="265" r:id="R1677adc79e464162"/>
-    <p:sldId xmlns:r="http://schemas.openxmlformats.org/officeDocument/2006/relationships" id="266" r:id="R66d3fbf5309b48f9"/>
-    <p:sldId xmlns:r="http://schemas.openxmlformats.org/officeDocument/2006/relationships" id="267" r:id="Rac3e8b2b59bc4712"/>
-    <p:sldId xmlns:r="http://schemas.openxmlformats.org/officeDocument/2006/relationships" id="268" r:id="R27a5ee238809449c"/>
-    <p:sldId xmlns:r="http://schemas.openxmlformats.org/officeDocument/2006/relationships" id="269" r:id="Ra2dcd76e134049c7"/>
-    <p:sldId xmlns:r="http://schemas.openxmlformats.org/officeDocument/2006/relationships" id="270" r:id="R501533d2aa0c4823"/>
-    <p:sldId xmlns:r="http://schemas.openxmlformats.org/officeDocument/2006/relationships" id="271" r:id="Re0aba1c9f74a46ce"/>
+    <p:sldId xmlns:r="http://schemas.openxmlformats.org/officeDocument/2006/relationships" id="256" r:id="Rc9841e1ebaf64edf"/>
+    <p:sldId xmlns:r="http://schemas.openxmlformats.org/officeDocument/2006/relationships" id="257" r:id="R69823589fbec47db"/>
+    <p:sldId xmlns:r="http://schemas.openxmlformats.org/officeDocument/2006/relationships" id="258" r:id="R9706f6930ae44197"/>
+    <p:sldId xmlns:r="http://schemas.openxmlformats.org/officeDocument/2006/relationships" id="259" r:id="R8e997cf674ca4930"/>
+    <p:sldId xmlns:r="http://schemas.openxmlformats.org/officeDocument/2006/relationships" id="260" r:id="Re699a025115c4794"/>
+    <p:sldId xmlns:r="http://schemas.openxmlformats.org/officeDocument/2006/relationships" id="261" r:id="Rbac6c8786a714291"/>
+    <p:sldId xmlns:r="http://schemas.openxmlformats.org/officeDocument/2006/relationships" id="262" r:id="R71a6be97aa8e4208"/>
+    <p:sldId xmlns:r="http://schemas.openxmlformats.org/officeDocument/2006/relationships" id="263" r:id="Rcfcec0f6e46c4203"/>
+    <p:sldId xmlns:r="http://schemas.openxmlformats.org/officeDocument/2006/relationships" id="264" r:id="R7e4aa3045c5b4921"/>
+    <p:sldId xmlns:r="http://schemas.openxmlformats.org/officeDocument/2006/relationships" id="265" r:id="Rd7343d87f6ae4a0e"/>
+    <p:sldId xmlns:r="http://schemas.openxmlformats.org/officeDocument/2006/relationships" id="266" r:id="Rceb80d71efaf4c63"/>
+    <p:sldId xmlns:r="http://schemas.openxmlformats.org/officeDocument/2006/relationships" id="267" r:id="Re1216420b370473e"/>
+    <p:sldId xmlns:r="http://schemas.openxmlformats.org/officeDocument/2006/relationships" id="268" r:id="Rd0f9d7004b7e4607"/>
+    <p:sldId xmlns:r="http://schemas.openxmlformats.org/officeDocument/2006/relationships" id="269" r:id="R340560254ece4ea1"/>
+    <p:sldId xmlns:r="http://schemas.openxmlformats.org/officeDocument/2006/relationships" id="270" r:id="R8b4b6718da6f4770"/>
+    <p:sldId xmlns:r="http://schemas.openxmlformats.org/officeDocument/2006/relationships" id="271" r:id="R5f9e271ffec44723"/>
   </p:sldIdLst>
   <p:sldSz cx="12192000" cy="6858000"/>
   <p:notesSz cx="6858000" cy="9144000"/>
@@ -1574,7 +1574,7 @@
   </p:cSld>
   <p:clrMap bg1="lt1" tx1="dk1" bg2="lt2" tx2="dk2" accent1="accent1" accent2="accent2" accent3="accent3" accent4="accent4" accent5="accent5" accent6="accent6" hlink="hlink" folHlink="folHlink"/>
   <p:sldLayoutIdLst>
-    <p:sldLayoutId xmlns:r="http://schemas.openxmlformats.org/officeDocument/2006/relationships" id="2147483649" r:id="R845d264b8c204929"/>
+    <p:sldLayoutId xmlns:r="http://schemas.openxmlformats.org/officeDocument/2006/relationships" id="2147483649" r:id="Rb2bdefa60c8d4f40"/>
   </p:sldLayoutIdLst>
   <p:hf sldNum="0" hdr="0" ftr="0" dt="0"/>
   <p:txStyles>
@@ -2127,7 +2127,7 @@
     <p:bg>
       <p:bgPr>
         <a:blipFill xmlns:a="http://schemas.openxmlformats.org/drawingml/2006/main" rotWithShape="1">
-          <a:blip xmlns:r="http://schemas.openxmlformats.org/officeDocument/2006/relationships" r:embed="R623470dceb964847">
+          <a:blip xmlns:r="http://schemas.openxmlformats.org/officeDocument/2006/relationships" r:embed="R864265e3377b40fe">
             <a:lum/>
           </a:blip>
           <a:srcRect l="0" t="0" r="0" b="0"/>
@@ -2155,7 +2155,7 @@
           <p:nvPr/>
         </p:nvPicPr>
         <p:blipFill>
-          <a:blip xmlns:r="http://schemas.openxmlformats.org/officeDocument/2006/relationships" xmlns:a="http://schemas.openxmlformats.org/drawingml/2006/main" r:embed="R23aaafc4e034482a"/>
+          <a:blip xmlns:r="http://schemas.openxmlformats.org/officeDocument/2006/relationships" xmlns:a="http://schemas.openxmlformats.org/drawingml/2006/main" r:embed="R67b6149c491d4a63"/>
           <a:stretch xmlns:a="http://schemas.openxmlformats.org/drawingml/2006/main">
             <a:fillRect l="0" t="0" r="0" b="0"/>
           </a:stretch>
@@ -2179,7 +2179,7 @@
           <p:nvPr/>
         </p:nvPicPr>
         <p:blipFill>
-          <a:blip xmlns:r="http://schemas.openxmlformats.org/officeDocument/2006/relationships" xmlns:a="http://schemas.openxmlformats.org/drawingml/2006/main" r:embed="Rad1c0255e80344a9"/>
+          <a:blip xmlns:r="http://schemas.openxmlformats.org/officeDocument/2006/relationships" xmlns:a="http://schemas.openxmlformats.org/drawingml/2006/main" r:embed="Rcd1e57af70b7493d"/>
           <a:stretch xmlns:a="http://schemas.openxmlformats.org/drawingml/2006/main">
             <a:fillRect l="0" t="0" r="0" b="0"/>
           </a:stretch>
@@ -2712,7 +2712,7 @@
           <p:nvPr/>
         </p:nvPicPr>
         <p:blipFill>
-          <a:blip xmlns:r="http://schemas.openxmlformats.org/officeDocument/2006/relationships" xmlns:a="http://schemas.openxmlformats.org/drawingml/2006/main" r:embed="R98571ed7ffb64e2c"/>
+          <a:blip xmlns:r="http://schemas.openxmlformats.org/officeDocument/2006/relationships" xmlns:a="http://schemas.openxmlformats.org/drawingml/2006/main" r:embed="Re6b3f27a2656468b"/>
           <a:stretch xmlns:a="http://schemas.openxmlformats.org/drawingml/2006/main">
             <a:fillRect l="0" t="0" r="0" b="0"/>
           </a:stretch>
@@ -2736,7 +2736,7 @@
           <p:nvPr/>
         </p:nvPicPr>
         <p:blipFill>
-          <a:blip xmlns:r="http://schemas.openxmlformats.org/officeDocument/2006/relationships" xmlns:a="http://schemas.openxmlformats.org/drawingml/2006/main" r:embed="Rab70c94a864d449f"/>
+          <a:blip xmlns:r="http://schemas.openxmlformats.org/officeDocument/2006/relationships" xmlns:a="http://schemas.openxmlformats.org/drawingml/2006/main" r:embed="R2840dbc2793f473d"/>
           <a:stretch xmlns:a="http://schemas.openxmlformats.org/drawingml/2006/main">
             <a:fillRect l="0" t="0" r="0" b="0"/>
           </a:stretch>
@@ -2962,7 +2962,7 @@
           <p:nvPr/>
         </p:nvPicPr>
         <p:blipFill>
-          <a:blip xmlns:r="http://schemas.openxmlformats.org/officeDocument/2006/relationships" xmlns:a="http://schemas.openxmlformats.org/drawingml/2006/main" r:embed="R56f45f49f25043e4"/>
+          <a:blip xmlns:r="http://schemas.openxmlformats.org/officeDocument/2006/relationships" xmlns:a="http://schemas.openxmlformats.org/drawingml/2006/main" r:embed="R8b12cb379da24ad3"/>
           <a:stretch xmlns:a="http://schemas.openxmlformats.org/drawingml/2006/main">
             <a:fillRect l="0" t="0" r="0" b="0"/>
           </a:stretch>
@@ -3039,7 +3039,7 @@
           <p:nvPr/>
         </p:nvPicPr>
         <p:blipFill>
-          <a:blip xmlns:r="http://schemas.openxmlformats.org/officeDocument/2006/relationships" xmlns:a="http://schemas.openxmlformats.org/drawingml/2006/main" r:embed="R9628d5927d6042aa"/>
+          <a:blip xmlns:r="http://schemas.openxmlformats.org/officeDocument/2006/relationships" xmlns:a="http://schemas.openxmlformats.org/drawingml/2006/main" r:embed="Ra4ae280410da40d2"/>
           <a:stretch xmlns:a="http://schemas.openxmlformats.org/drawingml/2006/main">
             <a:fillRect l="0" t="0" r="0" b="0"/>
           </a:stretch>
@@ -3116,7 +3116,7 @@
           <p:nvPr/>
         </p:nvPicPr>
         <p:blipFill>
-          <a:blip xmlns:r="http://schemas.openxmlformats.org/officeDocument/2006/relationships" xmlns:a="http://schemas.openxmlformats.org/drawingml/2006/main" r:embed="R8b2c87632eb94902"/>
+          <a:blip xmlns:r="http://schemas.openxmlformats.org/officeDocument/2006/relationships" xmlns:a="http://schemas.openxmlformats.org/drawingml/2006/main" r:embed="R3f937856b59b41df"/>
           <a:stretch xmlns:a="http://schemas.openxmlformats.org/drawingml/2006/main">
             <a:fillRect l="0" t="0" r="0" b="0"/>
           </a:stretch>
@@ -3193,7 +3193,7 @@
           <p:nvPr/>
         </p:nvPicPr>
         <p:blipFill>
-          <a:blip xmlns:r="http://schemas.openxmlformats.org/officeDocument/2006/relationships" xmlns:a="http://schemas.openxmlformats.org/drawingml/2006/main" r:embed="R5d8d7277a29d4af0"/>
+          <a:blip xmlns:r="http://schemas.openxmlformats.org/officeDocument/2006/relationships" xmlns:a="http://schemas.openxmlformats.org/drawingml/2006/main" r:embed="Rdf19a3a974dd4f0e"/>
           <a:stretch xmlns:a="http://schemas.openxmlformats.org/drawingml/2006/main">
             <a:fillRect l="0" t="0" r="0" b="0"/>
           </a:stretch>
@@ -3270,7 +3270,7 @@
           <p:nvPr/>
         </p:nvPicPr>
         <p:blipFill>
-          <a:blip xmlns:r="http://schemas.openxmlformats.org/officeDocument/2006/relationships" xmlns:a="http://schemas.openxmlformats.org/drawingml/2006/main" r:embed="Racdf962fb41b479c"/>
+          <a:blip xmlns:r="http://schemas.openxmlformats.org/officeDocument/2006/relationships" xmlns:a="http://schemas.openxmlformats.org/drawingml/2006/main" r:embed="Rf0b4c1ed4b634132"/>
           <a:stretch xmlns:a="http://schemas.openxmlformats.org/drawingml/2006/main">
             <a:fillRect l="0" t="0" r="0" b="0"/>
           </a:stretch>
@@ -3347,7 +3347,7 @@
           <p:nvPr/>
         </p:nvPicPr>
         <p:blipFill>
-          <a:blip xmlns:r="http://schemas.openxmlformats.org/officeDocument/2006/relationships" xmlns:a="http://schemas.openxmlformats.org/drawingml/2006/main" r:embed="R8715200802cd480e"/>
+          <a:blip xmlns:r="http://schemas.openxmlformats.org/officeDocument/2006/relationships" xmlns:a="http://schemas.openxmlformats.org/drawingml/2006/main" r:embed="Ra3e9fd69fcc24fed"/>
           <a:stretch xmlns:a="http://schemas.openxmlformats.org/drawingml/2006/main">
             <a:fillRect l="0" t="0" r="0" b="0"/>
           </a:stretch>
@@ -3424,7 +3424,7 @@
           <p:nvPr/>
         </p:nvPicPr>
         <p:blipFill>
-          <a:blip xmlns:r="http://schemas.openxmlformats.org/officeDocument/2006/relationships" xmlns:a="http://schemas.openxmlformats.org/drawingml/2006/main" r:embed="R7fa38d22863d4efd"/>
+          <a:blip xmlns:r="http://schemas.openxmlformats.org/officeDocument/2006/relationships" xmlns:a="http://schemas.openxmlformats.org/drawingml/2006/main" r:embed="R9b8ba7a317f44772"/>
           <a:stretch xmlns:a="http://schemas.openxmlformats.org/drawingml/2006/main">
             <a:fillRect l="0" t="0" r="0" b="0"/>
           </a:stretch>
@@ -3704,7 +3704,7 @@
           <p:nvPr/>
         </p:nvPicPr>
         <p:blipFill>
-          <a:blip xmlns:r="http://schemas.openxmlformats.org/officeDocument/2006/relationships" xmlns:a="http://schemas.openxmlformats.org/drawingml/2006/main" r:embed="R79fa382e1fae477b"/>
+          <a:blip xmlns:r="http://schemas.openxmlformats.org/officeDocument/2006/relationships" xmlns:a="http://schemas.openxmlformats.org/drawingml/2006/main" r:embed="R2e58ce35cd6e496e"/>
           <a:stretch xmlns:a="http://schemas.openxmlformats.org/drawingml/2006/main">
             <a:fillRect l="0" t="0" r="0" b="0"/>
           </a:stretch>
@@ -3882,7 +3882,7 @@
           <p:nvPr/>
         </p:nvPicPr>
         <p:blipFill>
-          <a:blip xmlns:r="http://schemas.openxmlformats.org/officeDocument/2006/relationships" xmlns:a="http://schemas.openxmlformats.org/drawingml/2006/main" r:embed="R9dbb35e07c3243eb"/>
+          <a:blip xmlns:r="http://schemas.openxmlformats.org/officeDocument/2006/relationships" xmlns:a="http://schemas.openxmlformats.org/drawingml/2006/main" r:embed="R6896e8476b184013"/>
           <a:stretch xmlns:a="http://schemas.openxmlformats.org/drawingml/2006/main">
             <a:fillRect l="0" t="0" r="0" b="0"/>
           </a:stretch>
@@ -3906,7 +3906,7 @@
           <p:nvPr/>
         </p:nvPicPr>
         <p:blipFill>
-          <a:blip xmlns:r="http://schemas.openxmlformats.org/officeDocument/2006/relationships" xmlns:a="http://schemas.openxmlformats.org/drawingml/2006/main" r:embed="Rad15a70dfd6041f7"/>
+          <a:blip xmlns:r="http://schemas.openxmlformats.org/officeDocument/2006/relationships" xmlns:a="http://schemas.openxmlformats.org/drawingml/2006/main" r:embed="R002c1b5088d34b8c"/>
           <a:stretch xmlns:a="http://schemas.openxmlformats.org/drawingml/2006/main">
             <a:fillRect l="0" t="0" r="0" b="0"/>
           </a:stretch>
@@ -4758,7 +4758,7 @@
           <p:nvPr/>
         </p:nvPicPr>
         <p:blipFill>
-          <a:blip xmlns:r="http://schemas.openxmlformats.org/officeDocument/2006/relationships" xmlns:a="http://schemas.openxmlformats.org/drawingml/2006/main" r:embed="Ra4e1e74a98e04e4f"/>
+          <a:blip xmlns:r="http://schemas.openxmlformats.org/officeDocument/2006/relationships" xmlns:a="http://schemas.openxmlformats.org/drawingml/2006/main" r:embed="R132bc0ab61e040a5"/>
           <a:stretch xmlns:a="http://schemas.openxmlformats.org/drawingml/2006/main">
             <a:fillRect l="0" t="0" r="0" b="0"/>
           </a:stretch>
@@ -4782,7 +4782,7 @@
           <p:nvPr/>
         </p:nvPicPr>
         <p:blipFill>
-          <a:blip xmlns:r="http://schemas.openxmlformats.org/officeDocument/2006/relationships" xmlns:a="http://schemas.openxmlformats.org/drawingml/2006/main" r:embed="R85f9b99aa40f44c9"/>
+          <a:blip xmlns:r="http://schemas.openxmlformats.org/officeDocument/2006/relationships" xmlns:a="http://schemas.openxmlformats.org/drawingml/2006/main" r:embed="Redc487b3c7f64deb"/>
           <a:stretch xmlns:a="http://schemas.openxmlformats.org/drawingml/2006/main">
             <a:fillRect l="0" t="0" r="0" b="0"/>
           </a:stretch>
@@ -5628,7 +5628,7 @@
           <p:nvPr/>
         </p:nvPicPr>
         <p:blipFill>
-          <a:blip xmlns:r="http://schemas.openxmlformats.org/officeDocument/2006/relationships" xmlns:a="http://schemas.openxmlformats.org/drawingml/2006/main" r:embed="R40b08ef1375a43c9"/>
+          <a:blip xmlns:r="http://schemas.openxmlformats.org/officeDocument/2006/relationships" xmlns:a="http://schemas.openxmlformats.org/drawingml/2006/main" r:embed="R7a3528cc9a0c463b"/>
           <a:stretch xmlns:a="http://schemas.openxmlformats.org/drawingml/2006/main">
             <a:fillRect l="0" t="0" r="0" b="0"/>
           </a:stretch>
@@ -5652,7 +5652,7 @@
           <p:nvPr/>
         </p:nvPicPr>
         <p:blipFill>
-          <a:blip xmlns:r="http://schemas.openxmlformats.org/officeDocument/2006/relationships" xmlns:a="http://schemas.openxmlformats.org/drawingml/2006/main" r:embed="R590eb92cdea8438d"/>
+          <a:blip xmlns:r="http://schemas.openxmlformats.org/officeDocument/2006/relationships" xmlns:a="http://schemas.openxmlformats.org/drawingml/2006/main" r:embed="R67a357c9d5024b8f"/>
           <a:stretch xmlns:a="http://schemas.openxmlformats.org/drawingml/2006/main">
             <a:fillRect l="0" t="0" r="0" b="0"/>
           </a:stretch>
@@ -5878,7 +5878,7 @@
           <p:nvPr/>
         </p:nvPicPr>
         <p:blipFill>
-          <a:blip xmlns:r="http://schemas.openxmlformats.org/officeDocument/2006/relationships" xmlns:a="http://schemas.openxmlformats.org/drawingml/2006/main" r:embed="R6924e55e381a491c"/>
+          <a:blip xmlns:r="http://schemas.openxmlformats.org/officeDocument/2006/relationships" xmlns:a="http://schemas.openxmlformats.org/drawingml/2006/main" r:embed="R8bda21fb3ec74f32"/>
           <a:stretch xmlns:a="http://schemas.openxmlformats.org/drawingml/2006/main">
             <a:fillRect l="0" t="0" r="0" b="0"/>
           </a:stretch>
@@ -5955,7 +5955,7 @@
           <p:nvPr/>
         </p:nvPicPr>
         <p:blipFill>
-          <a:blip xmlns:r="http://schemas.openxmlformats.org/officeDocument/2006/relationships" xmlns:a="http://schemas.openxmlformats.org/drawingml/2006/main" r:embed="Rc290cb0d67dc4d8b"/>
+          <a:blip xmlns:r="http://schemas.openxmlformats.org/officeDocument/2006/relationships" xmlns:a="http://schemas.openxmlformats.org/drawingml/2006/main" r:embed="R5a6905fbeed84149"/>
           <a:stretch xmlns:a="http://schemas.openxmlformats.org/drawingml/2006/main">
             <a:fillRect l="0" t="0" r="0" b="0"/>
           </a:stretch>
@@ -6032,7 +6032,7 @@
           <p:nvPr/>
         </p:nvPicPr>
         <p:blipFill>
-          <a:blip xmlns:r="http://schemas.openxmlformats.org/officeDocument/2006/relationships" xmlns:a="http://schemas.openxmlformats.org/drawingml/2006/main" r:embed="R6cc73f4ae18f4352"/>
+          <a:blip xmlns:r="http://schemas.openxmlformats.org/officeDocument/2006/relationships" xmlns:a="http://schemas.openxmlformats.org/drawingml/2006/main" r:embed="R3a15eded56584660"/>
           <a:stretch xmlns:a="http://schemas.openxmlformats.org/drawingml/2006/main">
             <a:fillRect l="0" t="0" r="0" b="0"/>
           </a:stretch>
@@ -6109,7 +6109,7 @@
           <p:nvPr/>
         </p:nvPicPr>
         <p:blipFill>
-          <a:blip xmlns:r="http://schemas.openxmlformats.org/officeDocument/2006/relationships" xmlns:a="http://schemas.openxmlformats.org/drawingml/2006/main" r:embed="Rf406aac30c78439f"/>
+          <a:blip xmlns:r="http://schemas.openxmlformats.org/officeDocument/2006/relationships" xmlns:a="http://schemas.openxmlformats.org/drawingml/2006/main" r:embed="Ra162110dcc8646b8"/>
           <a:stretch xmlns:a="http://schemas.openxmlformats.org/drawingml/2006/main">
             <a:fillRect l="0" t="0" r="0" b="0"/>
           </a:stretch>
@@ -6186,7 +6186,7 @@
           <p:nvPr/>
         </p:nvPicPr>
         <p:blipFill>
-          <a:blip xmlns:r="http://schemas.openxmlformats.org/officeDocument/2006/relationships" xmlns:a="http://schemas.openxmlformats.org/drawingml/2006/main" r:embed="Rda1908e9a72b48a2"/>
+          <a:blip xmlns:r="http://schemas.openxmlformats.org/officeDocument/2006/relationships" xmlns:a="http://schemas.openxmlformats.org/drawingml/2006/main" r:embed="Rb1b1bc6c43554202"/>
           <a:stretch xmlns:a="http://schemas.openxmlformats.org/drawingml/2006/main">
             <a:fillRect l="0" t="0" r="0" b="0"/>
           </a:stretch>
@@ -6263,7 +6263,7 @@
           <p:nvPr/>
         </p:nvPicPr>
         <p:blipFill>
-          <a:blip xmlns:r="http://schemas.openxmlformats.org/officeDocument/2006/relationships" xmlns:a="http://schemas.openxmlformats.org/drawingml/2006/main" r:embed="R52bf0ea7f64f47be"/>
+          <a:blip xmlns:r="http://schemas.openxmlformats.org/officeDocument/2006/relationships" xmlns:a="http://schemas.openxmlformats.org/drawingml/2006/main" r:embed="R5711ace007cd4d34"/>
           <a:stretch xmlns:a="http://schemas.openxmlformats.org/drawingml/2006/main">
             <a:fillRect l="0" t="0" r="0" b="0"/>
           </a:stretch>
@@ -6340,7 +6340,7 @@
           <p:nvPr/>
         </p:nvPicPr>
         <p:blipFill>
-          <a:blip xmlns:r="http://schemas.openxmlformats.org/officeDocument/2006/relationships" xmlns:a="http://schemas.openxmlformats.org/drawingml/2006/main" r:embed="R5fec7cf319dc4f7d"/>
+          <a:blip xmlns:r="http://schemas.openxmlformats.org/officeDocument/2006/relationships" xmlns:a="http://schemas.openxmlformats.org/drawingml/2006/main" r:embed="Ree239a3d177e4037"/>
           <a:stretch xmlns:a="http://schemas.openxmlformats.org/drawingml/2006/main">
             <a:fillRect l="0" t="0" r="0" b="0"/>
           </a:stretch>
@@ -6620,7 +6620,7 @@
           <p:nvPr/>
         </p:nvPicPr>
         <p:blipFill>
-          <a:blip xmlns:r="http://schemas.openxmlformats.org/officeDocument/2006/relationships" xmlns:a="http://schemas.openxmlformats.org/drawingml/2006/main" r:embed="R77c1736fab8f4df1"/>
+          <a:blip xmlns:r="http://schemas.openxmlformats.org/officeDocument/2006/relationships" xmlns:a="http://schemas.openxmlformats.org/drawingml/2006/main" r:embed="Rb3ed58cac4c3436c"/>
           <a:stretch xmlns:a="http://schemas.openxmlformats.org/drawingml/2006/main">
             <a:fillRect l="0" t="0" r="0" b="0"/>
           </a:stretch>
@@ -6798,7 +6798,7 @@
           <p:nvPr/>
         </p:nvPicPr>
         <p:blipFill>
-          <a:blip xmlns:r="http://schemas.openxmlformats.org/officeDocument/2006/relationships" xmlns:a="http://schemas.openxmlformats.org/drawingml/2006/main" r:embed="R234de468efb34ad4"/>
+          <a:blip xmlns:r="http://schemas.openxmlformats.org/officeDocument/2006/relationships" xmlns:a="http://schemas.openxmlformats.org/drawingml/2006/main" r:embed="Rbdf22c3920964188"/>
           <a:stretch xmlns:a="http://schemas.openxmlformats.org/drawingml/2006/main">
             <a:fillRect l="0" t="0" r="0" b="0"/>
           </a:stretch>
@@ -6822,7 +6822,7 @@
           <p:nvPr/>
         </p:nvPicPr>
         <p:blipFill>
-          <a:blip xmlns:r="http://schemas.openxmlformats.org/officeDocument/2006/relationships" xmlns:a="http://schemas.openxmlformats.org/drawingml/2006/main" r:embed="R606704a2d94948c4"/>
+          <a:blip xmlns:r="http://schemas.openxmlformats.org/officeDocument/2006/relationships" xmlns:a="http://schemas.openxmlformats.org/drawingml/2006/main" r:embed="Rdb0b6770bc844163"/>
           <a:stretch xmlns:a="http://schemas.openxmlformats.org/drawingml/2006/main">
             <a:fillRect l="0" t="0" r="0" b="0"/>
           </a:stretch>
@@ -7663,7 +7663,7 @@
           <p:nvPr/>
         </p:nvPicPr>
         <p:blipFill>
-          <a:blip xmlns:r="http://schemas.openxmlformats.org/officeDocument/2006/relationships" xmlns:a="http://schemas.openxmlformats.org/drawingml/2006/main" r:embed="R682107c9f8794901"/>
+          <a:blip xmlns:r="http://schemas.openxmlformats.org/officeDocument/2006/relationships" xmlns:a="http://schemas.openxmlformats.org/drawingml/2006/main" r:embed="R2cd9169d752b4bf0"/>
           <a:stretch xmlns:a="http://schemas.openxmlformats.org/drawingml/2006/main">
             <a:fillRect l="0" t="0" r="0" b="0"/>
           </a:stretch>
@@ -7687,7 +7687,7 @@
           <p:nvPr/>
         </p:nvPicPr>
         <p:blipFill>
-          <a:blip xmlns:r="http://schemas.openxmlformats.org/officeDocument/2006/relationships" xmlns:a="http://schemas.openxmlformats.org/drawingml/2006/main" r:embed="Rc7cb11ba2dce4435"/>
+          <a:blip xmlns:r="http://schemas.openxmlformats.org/officeDocument/2006/relationships" xmlns:a="http://schemas.openxmlformats.org/drawingml/2006/main" r:embed="R6f4523748ce94e4c"/>
           <a:stretch xmlns:a="http://schemas.openxmlformats.org/drawingml/2006/main">
             <a:fillRect l="0" t="0" r="0" b="0"/>
           </a:stretch>
@@ -8213,7 +8213,7 @@
           <p:nvPr/>
         </p:nvPicPr>
         <p:blipFill>
-          <a:blip xmlns:r="http://schemas.openxmlformats.org/officeDocument/2006/relationships" xmlns:a="http://schemas.openxmlformats.org/drawingml/2006/main" r:embed="R53f13fd4f2bf4781"/>
+          <a:blip xmlns:r="http://schemas.openxmlformats.org/officeDocument/2006/relationships" xmlns:a="http://schemas.openxmlformats.org/drawingml/2006/main" r:embed="Rde06df208b9543b4"/>
           <a:stretch xmlns:a="http://schemas.openxmlformats.org/drawingml/2006/main">
             <a:fillRect l="0" t="0" r="0" b="0"/>
           </a:stretch>
@@ -8384,7 +8384,7 @@
           <p:nvPr/>
         </p:nvPicPr>
         <p:blipFill>
-          <a:blip xmlns:r="http://schemas.openxmlformats.org/officeDocument/2006/relationships" xmlns:a="http://schemas.openxmlformats.org/drawingml/2006/main" r:embed="R662ad243d86a425c"/>
+          <a:blip xmlns:r="http://schemas.openxmlformats.org/officeDocument/2006/relationships" xmlns:a="http://schemas.openxmlformats.org/drawingml/2006/main" r:embed="R79c8e29e09b34850"/>
           <a:stretch xmlns:a="http://schemas.openxmlformats.org/drawingml/2006/main">
             <a:fillRect l="0" t="0" r="0" b="0"/>
           </a:stretch>
@@ -8408,7 +8408,7 @@
           <p:nvPr/>
         </p:nvPicPr>
         <p:blipFill>
-          <a:blip xmlns:r="http://schemas.openxmlformats.org/officeDocument/2006/relationships" xmlns:a="http://schemas.openxmlformats.org/drawingml/2006/main" r:embed="R14cf8ed326bc4b15"/>
+          <a:blip xmlns:r="http://schemas.openxmlformats.org/officeDocument/2006/relationships" xmlns:a="http://schemas.openxmlformats.org/drawingml/2006/main" r:embed="R23c1d46adef84a10"/>
           <a:stretch xmlns:a="http://schemas.openxmlformats.org/drawingml/2006/main">
             <a:fillRect l="0" t="0" r="0" b="0"/>
           </a:stretch>
@@ -8934,7 +8934,7 @@
           <p:nvPr/>
         </p:nvPicPr>
         <p:blipFill>
-          <a:blip xmlns:r="http://schemas.openxmlformats.org/officeDocument/2006/relationships" xmlns:a="http://schemas.openxmlformats.org/drawingml/2006/main" r:embed="R6df85480159d4001"/>
+          <a:blip xmlns:r="http://schemas.openxmlformats.org/officeDocument/2006/relationships" xmlns:a="http://schemas.openxmlformats.org/drawingml/2006/main" r:embed="R91e4b51925dc4592"/>
           <a:stretch xmlns:a="http://schemas.openxmlformats.org/drawingml/2006/main">
             <a:fillRect l="0" t="0" r="0" b="0"/>
           </a:stretch>
@@ -9112,7 +9112,7 @@
           <p:nvPr/>
         </p:nvPicPr>
         <p:blipFill>
-          <a:blip xmlns:r="http://schemas.openxmlformats.org/officeDocument/2006/relationships" xmlns:a="http://schemas.openxmlformats.org/drawingml/2006/main" r:embed="Re7cf6e3da0d24377"/>
+          <a:blip xmlns:r="http://schemas.openxmlformats.org/officeDocument/2006/relationships" xmlns:a="http://schemas.openxmlformats.org/drawingml/2006/main" r:embed="Rfe94d57e08e74a96"/>
           <a:stretch xmlns:a="http://schemas.openxmlformats.org/drawingml/2006/main">
             <a:fillRect l="0" t="0" r="0" b="0"/>
           </a:stretch>
@@ -9136,7 +9136,7 @@
           <p:nvPr/>
         </p:nvPicPr>
         <p:blipFill>
-          <a:blip xmlns:r="http://schemas.openxmlformats.org/officeDocument/2006/relationships" xmlns:a="http://schemas.openxmlformats.org/drawingml/2006/main" r:embed="R08e85556b0f14150"/>
+          <a:blip xmlns:r="http://schemas.openxmlformats.org/officeDocument/2006/relationships" xmlns:a="http://schemas.openxmlformats.org/drawingml/2006/main" r:embed="R4e961f577fba42d0"/>
           <a:stretch xmlns:a="http://schemas.openxmlformats.org/drawingml/2006/main">
             <a:fillRect l="0" t="0" r="0" b="0"/>
           </a:stretch>
@@ -9391,7 +9391,7 @@
           <p:nvPr/>
         </p:nvPicPr>
         <p:blipFill>
-          <a:blip xmlns:r="http://schemas.openxmlformats.org/officeDocument/2006/relationships" xmlns:a="http://schemas.openxmlformats.org/drawingml/2006/main" r:embed="R045352294bcd45b4"/>
+          <a:blip xmlns:r="http://schemas.openxmlformats.org/officeDocument/2006/relationships" xmlns:a="http://schemas.openxmlformats.org/drawingml/2006/main" r:embed="Rbe31e0c9cde8423b"/>
           <a:stretch xmlns:a="http://schemas.openxmlformats.org/drawingml/2006/main">
             <a:fillRect l="0" t="0" r="0" b="0"/>
           </a:stretch>
@@ -9461,7 +9461,7 @@
           <p:nvPr/>
         </p:nvPicPr>
         <p:blipFill>
-          <a:blip xmlns:r="http://schemas.openxmlformats.org/officeDocument/2006/relationships" xmlns:a="http://schemas.openxmlformats.org/drawingml/2006/main" r:embed="Rf4ea8868ffaf4490"/>
+          <a:blip xmlns:r="http://schemas.openxmlformats.org/officeDocument/2006/relationships" xmlns:a="http://schemas.openxmlformats.org/drawingml/2006/main" r:embed="Rf72ea7fdc0e941c9"/>
           <a:stretch xmlns:a="http://schemas.openxmlformats.org/drawingml/2006/main">
             <a:fillRect l="0" t="0" r="0" b="0"/>
           </a:stretch>
@@ -9531,7 +9531,7 @@
           <p:nvPr/>
         </p:nvPicPr>
         <p:blipFill>
-          <a:blip xmlns:r="http://schemas.openxmlformats.org/officeDocument/2006/relationships" xmlns:a="http://schemas.openxmlformats.org/drawingml/2006/main" r:embed="Rbe128c76631b4049"/>
+          <a:blip xmlns:r="http://schemas.openxmlformats.org/officeDocument/2006/relationships" xmlns:a="http://schemas.openxmlformats.org/drawingml/2006/main" r:embed="R1050ab48e3a04ad9"/>
           <a:stretch xmlns:a="http://schemas.openxmlformats.org/drawingml/2006/main">
             <a:fillRect l="0" t="0" r="0" b="0"/>
           </a:stretch>
@@ -9601,7 +9601,7 @@
           <p:nvPr/>
         </p:nvPicPr>
         <p:blipFill>
-          <a:blip xmlns:r="http://schemas.openxmlformats.org/officeDocument/2006/relationships" xmlns:a="http://schemas.openxmlformats.org/drawingml/2006/main" r:embed="R09d4093199294b22"/>
+          <a:blip xmlns:r="http://schemas.openxmlformats.org/officeDocument/2006/relationships" xmlns:a="http://schemas.openxmlformats.org/drawingml/2006/main" r:embed="R0ad201dc54be4936"/>
           <a:stretch xmlns:a="http://schemas.openxmlformats.org/drawingml/2006/main">
             <a:fillRect l="0" t="0" r="0" b="0"/>
           </a:stretch>
@@ -9671,7 +9671,7 @@
           <p:nvPr/>
         </p:nvPicPr>
         <p:blipFill>
-          <a:blip xmlns:r="http://schemas.openxmlformats.org/officeDocument/2006/relationships" xmlns:a="http://schemas.openxmlformats.org/drawingml/2006/main" r:embed="R7fc88266e56248f9"/>
+          <a:blip xmlns:r="http://schemas.openxmlformats.org/officeDocument/2006/relationships" xmlns:a="http://schemas.openxmlformats.org/drawingml/2006/main" r:embed="R9d4cba835a5e49d6"/>
           <a:stretch xmlns:a="http://schemas.openxmlformats.org/drawingml/2006/main">
             <a:fillRect l="0" t="0" r="0" b="0"/>
           </a:stretch>
@@ -9741,7 +9741,7 @@
           <p:nvPr/>
         </p:nvPicPr>
         <p:blipFill>
-          <a:blip xmlns:r="http://schemas.openxmlformats.org/officeDocument/2006/relationships" xmlns:a="http://schemas.openxmlformats.org/drawingml/2006/main" r:embed="R38561233c82b4531"/>
+          <a:blip xmlns:r="http://schemas.openxmlformats.org/officeDocument/2006/relationships" xmlns:a="http://schemas.openxmlformats.org/drawingml/2006/main" r:embed="Reee97908b73449ee"/>
           <a:stretch xmlns:a="http://schemas.openxmlformats.org/drawingml/2006/main">
             <a:fillRect l="0" t="0" r="0" b="0"/>
           </a:stretch>
@@ -9811,7 +9811,7 @@
           <p:nvPr/>
         </p:nvPicPr>
         <p:blipFill>
-          <a:blip xmlns:r="http://schemas.openxmlformats.org/officeDocument/2006/relationships" xmlns:a="http://schemas.openxmlformats.org/drawingml/2006/main" r:embed="Rd11588ce9414432b"/>
+          <a:blip xmlns:r="http://schemas.openxmlformats.org/officeDocument/2006/relationships" xmlns:a="http://schemas.openxmlformats.org/drawingml/2006/main" r:embed="R3a119cf21a614f93"/>
           <a:stretch xmlns:a="http://schemas.openxmlformats.org/drawingml/2006/main">
             <a:fillRect l="0" t="0" r="0" b="0"/>
           </a:stretch>
@@ -9945,7 +9945,7 @@
                 <a:ea typeface="Calibri"/>
                 <a:cs typeface="Calibri"/>
               </a:rPr>
-              <a:t>BUKTI YANG DIKUMPULKAN</a:t>
+              <a:t>PROYEK KELOMPOK</a:t>
             </a:r>
           </a:p>
           <a:p xmlns:a="http://schemas.openxmlformats.org/drawingml/2006/main">
@@ -9974,7 +9974,7 @@
                 <a:ea typeface="Calibri"/>
                 <a:cs typeface="Calibri"/>
               </a:rPr>
-              <a:t>Hasil mesin sendiri</a:t>
+              <a:t>Tim 3 orang</a:t>
             </a:r>
             <a:endParaRPr sz="1100"/>
           </a:p>
@@ -10023,7 +10023,7 @@
                 <a:ea typeface="Calibri"/>
                 <a:cs typeface="Calibri"/>
               </a:rPr>
-              <a:t>1. Dockerfile dan source API</a:t>
+              <a:t>Image API menjadi backend proyek 3 orang</a:t>
             </a:r>
           </a:p>
           <a:p xmlns:a="http://schemas.openxmlformats.org/drawingml/2006/main">
@@ -10042,7 +10042,7 @@
                 <a:ea typeface="Calibri"/>
                 <a:cs typeface="Calibri"/>
               </a:rPr>
-              <a:t>2. Bukti build, OpenAPI, HTTP</a:t>
+              <a:t>Uji health, REST, dan validasi</a:t>
             </a:r>
           </a:p>
           <a:p xmlns:a="http://schemas.openxmlformats.org/drawingml/2006/main">
@@ -10061,7 +10061,7 @@
                 <a:ea typeface="Calibri"/>
                 <a:cs typeface="Calibri"/>
               </a:rPr>
-              <a:t>3. Kunci GET /stats pada salinan sendiri</a:t>
+              <a:t>Simpan bukti bila berguna</a:t>
             </a:r>
           </a:p>
           <a:p xmlns:a="http://schemas.openxmlformats.org/drawingml/2006/main">
@@ -10080,7 +10080,7 @@
                 <a:ea typeface="Calibri"/>
                 <a:cs typeface="Calibri"/>
               </a:rPr>
-              <a:t>4. Commit Git tanpa secret</a:t>
+              <a:t>Minggu 7 dan 14; tanpa nilai Lab 05</a:t>
             </a:r>
             <a:endParaRPr sz="1700"/>
           </a:p>
@@ -10328,7 +10328,7 @@
           <p:nvPr/>
         </p:nvPicPr>
         <p:blipFill>
-          <a:blip xmlns:r="http://schemas.openxmlformats.org/officeDocument/2006/relationships" xmlns:a="http://schemas.openxmlformats.org/drawingml/2006/main" r:embed="R5b9a18f427104fde"/>
+          <a:blip xmlns:r="http://schemas.openxmlformats.org/officeDocument/2006/relationships" xmlns:a="http://schemas.openxmlformats.org/drawingml/2006/main" r:embed="R257a2734a9f04d56"/>
           <a:stretch xmlns:a="http://schemas.openxmlformats.org/drawingml/2006/main">
             <a:fillRect l="0" t="0" r="0" b="0"/>
           </a:stretch>
@@ -10352,7 +10352,7 @@
           <p:nvPr/>
         </p:nvPicPr>
         <p:blipFill>
-          <a:blip xmlns:r="http://schemas.openxmlformats.org/officeDocument/2006/relationships" xmlns:a="http://schemas.openxmlformats.org/drawingml/2006/main" r:embed="Rf0eaa7ee8d3742d5"/>
+          <a:blip xmlns:r="http://schemas.openxmlformats.org/officeDocument/2006/relationships" xmlns:a="http://schemas.openxmlformats.org/drawingml/2006/main" r:embed="Rb37702c552b04247"/>
           <a:stretch xmlns:a="http://schemas.openxmlformats.org/drawingml/2006/main">
             <a:fillRect l="0" t="0" r="0" b="0"/>
           </a:stretch>
@@ -11197,7 +11197,7 @@
           <p:nvPr/>
         </p:nvPicPr>
         <p:blipFill>
-          <a:blip xmlns:r="http://schemas.openxmlformats.org/officeDocument/2006/relationships" xmlns:a="http://schemas.openxmlformats.org/drawingml/2006/main" r:embed="R8b0efb40406a46fa"/>
+          <a:blip xmlns:r="http://schemas.openxmlformats.org/officeDocument/2006/relationships" xmlns:a="http://schemas.openxmlformats.org/drawingml/2006/main" r:embed="Re7f6fc472d6b4c14"/>
           <a:stretch xmlns:a="http://schemas.openxmlformats.org/drawingml/2006/main">
             <a:fillRect l="0" t="0" r="0" b="0"/>
           </a:stretch>
@@ -11221,7 +11221,7 @@
           <p:nvPr/>
         </p:nvPicPr>
         <p:blipFill>
-          <a:blip xmlns:r="http://schemas.openxmlformats.org/officeDocument/2006/relationships" xmlns:a="http://schemas.openxmlformats.org/drawingml/2006/main" r:embed="Rc7c83f3cd7da485d"/>
+          <a:blip xmlns:r="http://schemas.openxmlformats.org/officeDocument/2006/relationships" xmlns:a="http://schemas.openxmlformats.org/drawingml/2006/main" r:embed="R60670b5c1fad46fb"/>
           <a:stretch xmlns:a="http://schemas.openxmlformats.org/drawingml/2006/main">
             <a:fillRect l="0" t="0" r="0" b="0"/>
           </a:stretch>
@@ -11447,7 +11447,7 @@
           <p:nvPr/>
         </p:nvPicPr>
         <p:blipFill>
-          <a:blip xmlns:r="http://schemas.openxmlformats.org/officeDocument/2006/relationships" xmlns:a="http://schemas.openxmlformats.org/drawingml/2006/main" r:embed="Ra514c3bd6e5647db"/>
+          <a:blip xmlns:r="http://schemas.openxmlformats.org/officeDocument/2006/relationships" xmlns:a="http://schemas.openxmlformats.org/drawingml/2006/main" r:embed="R1570aa2bd3bc40e8"/>
           <a:stretch xmlns:a="http://schemas.openxmlformats.org/drawingml/2006/main">
             <a:fillRect l="0" t="0" r="0" b="0"/>
           </a:stretch>
@@ -11524,7 +11524,7 @@
           <p:nvPr/>
         </p:nvPicPr>
         <p:blipFill>
-          <a:blip xmlns:r="http://schemas.openxmlformats.org/officeDocument/2006/relationships" xmlns:a="http://schemas.openxmlformats.org/drawingml/2006/main" r:embed="R9acf349157914bb3"/>
+          <a:blip xmlns:r="http://schemas.openxmlformats.org/officeDocument/2006/relationships" xmlns:a="http://schemas.openxmlformats.org/drawingml/2006/main" r:embed="Rdc140ace6cb74bdf"/>
           <a:stretch xmlns:a="http://schemas.openxmlformats.org/drawingml/2006/main">
             <a:fillRect l="0" t="0" r="0" b="0"/>
           </a:stretch>
@@ -11601,7 +11601,7 @@
           <p:nvPr/>
         </p:nvPicPr>
         <p:blipFill>
-          <a:blip xmlns:r="http://schemas.openxmlformats.org/officeDocument/2006/relationships" xmlns:a="http://schemas.openxmlformats.org/drawingml/2006/main" r:embed="R120ae575521641ca"/>
+          <a:blip xmlns:r="http://schemas.openxmlformats.org/officeDocument/2006/relationships" xmlns:a="http://schemas.openxmlformats.org/drawingml/2006/main" r:embed="R9431502cc7fb4ee1"/>
           <a:stretch xmlns:a="http://schemas.openxmlformats.org/drawingml/2006/main">
             <a:fillRect l="0" t="0" r="0" b="0"/>
           </a:stretch>
@@ -11678,7 +11678,7 @@
           <p:nvPr/>
         </p:nvPicPr>
         <p:blipFill>
-          <a:blip xmlns:r="http://schemas.openxmlformats.org/officeDocument/2006/relationships" xmlns:a="http://schemas.openxmlformats.org/drawingml/2006/main" r:embed="R275c58d19a6c4f73"/>
+          <a:blip xmlns:r="http://schemas.openxmlformats.org/officeDocument/2006/relationships" xmlns:a="http://schemas.openxmlformats.org/drawingml/2006/main" r:embed="R6da2b15dc6044c80"/>
           <a:stretch xmlns:a="http://schemas.openxmlformats.org/drawingml/2006/main">
             <a:fillRect l="0" t="0" r="0" b="0"/>
           </a:stretch>
@@ -11755,7 +11755,7 @@
           <p:nvPr/>
         </p:nvPicPr>
         <p:blipFill>
-          <a:blip xmlns:r="http://schemas.openxmlformats.org/officeDocument/2006/relationships" xmlns:a="http://schemas.openxmlformats.org/drawingml/2006/main" r:embed="Rb141944f28124cd5"/>
+          <a:blip xmlns:r="http://schemas.openxmlformats.org/officeDocument/2006/relationships" xmlns:a="http://schemas.openxmlformats.org/drawingml/2006/main" r:embed="R16df7939284c4a94"/>
           <a:stretch xmlns:a="http://schemas.openxmlformats.org/drawingml/2006/main">
             <a:fillRect l="0" t="0" r="0" b="0"/>
           </a:stretch>
@@ -11832,7 +11832,7 @@
           <p:nvPr/>
         </p:nvPicPr>
         <p:blipFill>
-          <a:blip xmlns:r="http://schemas.openxmlformats.org/officeDocument/2006/relationships" xmlns:a="http://schemas.openxmlformats.org/drawingml/2006/main" r:embed="R55d4c8c61da64964"/>
+          <a:blip xmlns:r="http://schemas.openxmlformats.org/officeDocument/2006/relationships" xmlns:a="http://schemas.openxmlformats.org/drawingml/2006/main" r:embed="R70dc438c28a840c6"/>
           <a:stretch xmlns:a="http://schemas.openxmlformats.org/drawingml/2006/main">
             <a:fillRect l="0" t="0" r="0" b="0"/>
           </a:stretch>
@@ -11909,7 +11909,7 @@
           <p:nvPr/>
         </p:nvPicPr>
         <p:blipFill>
-          <a:blip xmlns:r="http://schemas.openxmlformats.org/officeDocument/2006/relationships" xmlns:a="http://schemas.openxmlformats.org/drawingml/2006/main" r:embed="Radc0fc7dd3a642a7"/>
+          <a:blip xmlns:r="http://schemas.openxmlformats.org/officeDocument/2006/relationships" xmlns:a="http://schemas.openxmlformats.org/drawingml/2006/main" r:embed="R77a6a2e8d6444464"/>
           <a:stretch xmlns:a="http://schemas.openxmlformats.org/drawingml/2006/main">
             <a:fillRect l="0" t="0" r="0" b="0"/>
           </a:stretch>
@@ -12189,7 +12189,7 @@
           <p:nvPr/>
         </p:nvPicPr>
         <p:blipFill>
-          <a:blip xmlns:r="http://schemas.openxmlformats.org/officeDocument/2006/relationships" xmlns:a="http://schemas.openxmlformats.org/drawingml/2006/main" r:embed="R165ebc4d6c0b4607"/>
+          <a:blip xmlns:r="http://schemas.openxmlformats.org/officeDocument/2006/relationships" xmlns:a="http://schemas.openxmlformats.org/drawingml/2006/main" r:embed="R701913ec347845d4"/>
           <a:stretch xmlns:a="http://schemas.openxmlformats.org/drawingml/2006/main">
             <a:fillRect l="0" t="0" r="0" b="0"/>
           </a:stretch>
@@ -12367,7 +12367,7 @@
           <p:nvPr/>
         </p:nvPicPr>
         <p:blipFill>
-          <a:blip xmlns:r="http://schemas.openxmlformats.org/officeDocument/2006/relationships" xmlns:a="http://schemas.openxmlformats.org/drawingml/2006/main" r:embed="Rba5eeaf9294f4c29"/>
+          <a:blip xmlns:r="http://schemas.openxmlformats.org/officeDocument/2006/relationships" xmlns:a="http://schemas.openxmlformats.org/drawingml/2006/main" r:embed="Rfab7b962157b421e"/>
           <a:stretch xmlns:a="http://schemas.openxmlformats.org/drawingml/2006/main">
             <a:fillRect l="0" t="0" r="0" b="0"/>
           </a:stretch>
@@ -12391,7 +12391,7 @@
           <p:nvPr/>
         </p:nvPicPr>
         <p:blipFill>
-          <a:blip xmlns:r="http://schemas.openxmlformats.org/officeDocument/2006/relationships" xmlns:a="http://schemas.openxmlformats.org/drawingml/2006/main" r:embed="R5b15560ddd8e47b4"/>
+          <a:blip xmlns:r="http://schemas.openxmlformats.org/officeDocument/2006/relationships" xmlns:a="http://schemas.openxmlformats.org/drawingml/2006/main" r:embed="R5ad0badfd63c4c78"/>
           <a:stretch xmlns:a="http://schemas.openxmlformats.org/drawingml/2006/main">
             <a:fillRect l="0" t="0" r="0" b="0"/>
           </a:stretch>
@@ -13237,7 +13237,7 @@
           <p:nvPr/>
         </p:nvPicPr>
         <p:blipFill>
-          <a:blip xmlns:r="http://schemas.openxmlformats.org/officeDocument/2006/relationships" xmlns:a="http://schemas.openxmlformats.org/drawingml/2006/main" r:embed="Ref9382825a844ce7"/>
+          <a:blip xmlns:r="http://schemas.openxmlformats.org/officeDocument/2006/relationships" xmlns:a="http://schemas.openxmlformats.org/drawingml/2006/main" r:embed="R038c51967eea400c"/>
           <a:stretch xmlns:a="http://schemas.openxmlformats.org/drawingml/2006/main">
             <a:fillRect l="0" t="0" r="0" b="0"/>
           </a:stretch>
@@ -13261,7 +13261,7 @@
           <p:nvPr/>
         </p:nvPicPr>
         <p:blipFill>
-          <a:blip xmlns:r="http://schemas.openxmlformats.org/officeDocument/2006/relationships" xmlns:a="http://schemas.openxmlformats.org/drawingml/2006/main" r:embed="R949d58023c374315"/>
+          <a:blip xmlns:r="http://schemas.openxmlformats.org/officeDocument/2006/relationships" xmlns:a="http://schemas.openxmlformats.org/drawingml/2006/main" r:embed="R0d0de55503dd42a9"/>
           <a:stretch xmlns:a="http://schemas.openxmlformats.org/drawingml/2006/main">
             <a:fillRect l="0" t="0" r="0" b="0"/>
           </a:stretch>
@@ -13487,7 +13487,7 @@
           <p:nvPr/>
         </p:nvPicPr>
         <p:blipFill>
-          <a:blip xmlns:r="http://schemas.openxmlformats.org/officeDocument/2006/relationships" xmlns:a="http://schemas.openxmlformats.org/drawingml/2006/main" r:embed="Raa30662146ab4064"/>
+          <a:blip xmlns:r="http://schemas.openxmlformats.org/officeDocument/2006/relationships" xmlns:a="http://schemas.openxmlformats.org/drawingml/2006/main" r:embed="R8ca421e5ae0a4011"/>
           <a:stretch xmlns:a="http://schemas.openxmlformats.org/drawingml/2006/main">
             <a:fillRect l="0" t="0" r="0" b="0"/>
           </a:stretch>
@@ -13564,7 +13564,7 @@
           <p:nvPr/>
         </p:nvPicPr>
         <p:blipFill>
-          <a:blip xmlns:r="http://schemas.openxmlformats.org/officeDocument/2006/relationships" xmlns:a="http://schemas.openxmlformats.org/drawingml/2006/main" r:embed="R2258d3c5b78e4486"/>
+          <a:blip xmlns:r="http://schemas.openxmlformats.org/officeDocument/2006/relationships" xmlns:a="http://schemas.openxmlformats.org/drawingml/2006/main" r:embed="R8aa6fa9adacc4890"/>
           <a:stretch xmlns:a="http://schemas.openxmlformats.org/drawingml/2006/main">
             <a:fillRect l="0" t="0" r="0" b="0"/>
           </a:stretch>
@@ -13641,7 +13641,7 @@
           <p:nvPr/>
         </p:nvPicPr>
         <p:blipFill>
-          <a:blip xmlns:r="http://schemas.openxmlformats.org/officeDocument/2006/relationships" xmlns:a="http://schemas.openxmlformats.org/drawingml/2006/main" r:embed="R2585a86d0fc44d36"/>
+          <a:blip xmlns:r="http://schemas.openxmlformats.org/officeDocument/2006/relationships" xmlns:a="http://schemas.openxmlformats.org/drawingml/2006/main" r:embed="Rc84fcb3c83c24245"/>
           <a:stretch xmlns:a="http://schemas.openxmlformats.org/drawingml/2006/main">
             <a:fillRect l="0" t="0" r="0" b="0"/>
           </a:stretch>
@@ -13718,7 +13718,7 @@
           <p:nvPr/>
         </p:nvPicPr>
         <p:blipFill>
-          <a:blip xmlns:r="http://schemas.openxmlformats.org/officeDocument/2006/relationships" xmlns:a="http://schemas.openxmlformats.org/drawingml/2006/main" r:embed="R88ecccedd4984f4d"/>
+          <a:blip xmlns:r="http://schemas.openxmlformats.org/officeDocument/2006/relationships" xmlns:a="http://schemas.openxmlformats.org/drawingml/2006/main" r:embed="R66cb67d433704a30"/>
           <a:stretch xmlns:a="http://schemas.openxmlformats.org/drawingml/2006/main">
             <a:fillRect l="0" t="0" r="0" b="0"/>
           </a:stretch>
@@ -13795,7 +13795,7 @@
           <p:nvPr/>
         </p:nvPicPr>
         <p:blipFill>
-          <a:blip xmlns:r="http://schemas.openxmlformats.org/officeDocument/2006/relationships" xmlns:a="http://schemas.openxmlformats.org/drawingml/2006/main" r:embed="Rf2b9ce302c17458c"/>
+          <a:blip xmlns:r="http://schemas.openxmlformats.org/officeDocument/2006/relationships" xmlns:a="http://schemas.openxmlformats.org/drawingml/2006/main" r:embed="R7b1170ab403c4711"/>
           <a:stretch xmlns:a="http://schemas.openxmlformats.org/drawingml/2006/main">
             <a:fillRect l="0" t="0" r="0" b="0"/>
           </a:stretch>
@@ -13872,7 +13872,7 @@
           <p:nvPr/>
         </p:nvPicPr>
         <p:blipFill>
-          <a:blip xmlns:r="http://schemas.openxmlformats.org/officeDocument/2006/relationships" xmlns:a="http://schemas.openxmlformats.org/drawingml/2006/main" r:embed="Rd0e6993403c144ff"/>
+          <a:blip xmlns:r="http://schemas.openxmlformats.org/officeDocument/2006/relationships" xmlns:a="http://schemas.openxmlformats.org/drawingml/2006/main" r:embed="R6494c50c94d64f72"/>
           <a:stretch xmlns:a="http://schemas.openxmlformats.org/drawingml/2006/main">
             <a:fillRect l="0" t="0" r="0" b="0"/>
           </a:stretch>
@@ -13949,7 +13949,7 @@
           <p:nvPr/>
         </p:nvPicPr>
         <p:blipFill>
-          <a:blip xmlns:r="http://schemas.openxmlformats.org/officeDocument/2006/relationships" xmlns:a="http://schemas.openxmlformats.org/drawingml/2006/main" r:embed="R1d4f2ead1d7f4512"/>
+          <a:blip xmlns:r="http://schemas.openxmlformats.org/officeDocument/2006/relationships" xmlns:a="http://schemas.openxmlformats.org/drawingml/2006/main" r:embed="Rb25e505141b54093"/>
           <a:stretch xmlns:a="http://schemas.openxmlformats.org/drawingml/2006/main">
             <a:fillRect l="0" t="0" r="0" b="0"/>
           </a:stretch>
@@ -14229,7 +14229,7 @@
           <p:nvPr/>
         </p:nvPicPr>
         <p:blipFill>
-          <a:blip xmlns:r="http://schemas.openxmlformats.org/officeDocument/2006/relationships" xmlns:a="http://schemas.openxmlformats.org/drawingml/2006/main" r:embed="Ra5d1115cc744484d"/>
+          <a:blip xmlns:r="http://schemas.openxmlformats.org/officeDocument/2006/relationships" xmlns:a="http://schemas.openxmlformats.org/drawingml/2006/main" r:embed="Rbd5ff9e4810c4f90"/>
           <a:stretch xmlns:a="http://schemas.openxmlformats.org/drawingml/2006/main">
             <a:fillRect l="0" t="0" r="0" b="0"/>
           </a:stretch>
@@ -14407,7 +14407,7 @@
           <p:nvPr/>
         </p:nvPicPr>
         <p:blipFill>
-          <a:blip xmlns:r="http://schemas.openxmlformats.org/officeDocument/2006/relationships" xmlns:a="http://schemas.openxmlformats.org/drawingml/2006/main" r:embed="R0ef45a1b9af54cd6"/>
+          <a:blip xmlns:r="http://schemas.openxmlformats.org/officeDocument/2006/relationships" xmlns:a="http://schemas.openxmlformats.org/drawingml/2006/main" r:embed="R806e762915ed4e40"/>
           <a:stretch xmlns:a="http://schemas.openxmlformats.org/drawingml/2006/main">
             <a:fillRect l="0" t="0" r="0" b="0"/>
           </a:stretch>
@@ -14431,7 +14431,7 @@
           <p:nvPr/>
         </p:nvPicPr>
         <p:blipFill>
-          <a:blip xmlns:r="http://schemas.openxmlformats.org/officeDocument/2006/relationships" xmlns:a="http://schemas.openxmlformats.org/drawingml/2006/main" r:embed="Rd7139cfccb304191"/>
+          <a:blip xmlns:r="http://schemas.openxmlformats.org/officeDocument/2006/relationships" xmlns:a="http://schemas.openxmlformats.org/drawingml/2006/main" r:embed="R43c73bf2f2e440e9"/>
           <a:stretch xmlns:a="http://schemas.openxmlformats.org/drawingml/2006/main">
             <a:fillRect l="0" t="0" r="0" b="0"/>
           </a:stretch>
@@ -15278,7 +15278,7 @@
           <p:nvPr/>
         </p:nvPicPr>
         <p:blipFill>
-          <a:blip xmlns:r="http://schemas.openxmlformats.org/officeDocument/2006/relationships" xmlns:a="http://schemas.openxmlformats.org/drawingml/2006/main" r:embed="Rc735da054a0b48c4"/>
+          <a:blip xmlns:r="http://schemas.openxmlformats.org/officeDocument/2006/relationships" xmlns:a="http://schemas.openxmlformats.org/drawingml/2006/main" r:embed="Rde2165bea3674356"/>
           <a:stretch xmlns:a="http://schemas.openxmlformats.org/drawingml/2006/main">
             <a:fillRect l="0" t="0" r="0" b="0"/>
           </a:stretch>
@@ -15302,7 +15302,7 @@
           <p:nvPr/>
         </p:nvPicPr>
         <p:blipFill>
-          <a:blip xmlns:r="http://schemas.openxmlformats.org/officeDocument/2006/relationships" xmlns:a="http://schemas.openxmlformats.org/drawingml/2006/main" r:embed="R2848ddacc7c64774"/>
+          <a:blip xmlns:r="http://schemas.openxmlformats.org/officeDocument/2006/relationships" xmlns:a="http://schemas.openxmlformats.org/drawingml/2006/main" r:embed="R5058e360d8534e42"/>
           <a:stretch xmlns:a="http://schemas.openxmlformats.org/drawingml/2006/main">
             <a:fillRect l="0" t="0" r="0" b="0"/>
           </a:stretch>
@@ -15528,7 +15528,7 @@
           <p:nvPr/>
         </p:nvPicPr>
         <p:blipFill>
-          <a:blip xmlns:r="http://schemas.openxmlformats.org/officeDocument/2006/relationships" xmlns:a="http://schemas.openxmlformats.org/drawingml/2006/main" r:embed="R5a294352522a4798"/>
+          <a:blip xmlns:r="http://schemas.openxmlformats.org/officeDocument/2006/relationships" xmlns:a="http://schemas.openxmlformats.org/drawingml/2006/main" r:embed="R69db179e8f604350"/>
           <a:stretch xmlns:a="http://schemas.openxmlformats.org/drawingml/2006/main">
             <a:fillRect l="0" t="0" r="0" b="0"/>
           </a:stretch>
@@ -15605,7 +15605,7 @@
           <p:nvPr/>
         </p:nvPicPr>
         <p:blipFill>
-          <a:blip xmlns:r="http://schemas.openxmlformats.org/officeDocument/2006/relationships" xmlns:a="http://schemas.openxmlformats.org/drawingml/2006/main" r:embed="R864b6823d2804fd6"/>
+          <a:blip xmlns:r="http://schemas.openxmlformats.org/officeDocument/2006/relationships" xmlns:a="http://schemas.openxmlformats.org/drawingml/2006/main" r:embed="Re54503822a0b45ad"/>
           <a:stretch xmlns:a="http://schemas.openxmlformats.org/drawingml/2006/main">
             <a:fillRect l="0" t="0" r="0" b="0"/>
           </a:stretch>
@@ -15682,7 +15682,7 @@
           <p:nvPr/>
         </p:nvPicPr>
         <p:blipFill>
-          <a:blip xmlns:r="http://schemas.openxmlformats.org/officeDocument/2006/relationships" xmlns:a="http://schemas.openxmlformats.org/drawingml/2006/main" r:embed="R39fc62ab1a90495e"/>
+          <a:blip xmlns:r="http://schemas.openxmlformats.org/officeDocument/2006/relationships" xmlns:a="http://schemas.openxmlformats.org/drawingml/2006/main" r:embed="R02b1a070913c4893"/>
           <a:stretch xmlns:a="http://schemas.openxmlformats.org/drawingml/2006/main">
             <a:fillRect l="0" t="0" r="0" b="0"/>
           </a:stretch>
@@ -15759,7 +15759,7 @@
           <p:nvPr/>
         </p:nvPicPr>
         <p:blipFill>
-          <a:blip xmlns:r="http://schemas.openxmlformats.org/officeDocument/2006/relationships" xmlns:a="http://schemas.openxmlformats.org/drawingml/2006/main" r:embed="R784a4c1611c84e17"/>
+          <a:blip xmlns:r="http://schemas.openxmlformats.org/officeDocument/2006/relationships" xmlns:a="http://schemas.openxmlformats.org/drawingml/2006/main" r:embed="Rff1f6007cb124582"/>
           <a:stretch xmlns:a="http://schemas.openxmlformats.org/drawingml/2006/main">
             <a:fillRect l="0" t="0" r="0" b="0"/>
           </a:stretch>
@@ -15836,7 +15836,7 @@
           <p:nvPr/>
         </p:nvPicPr>
         <p:blipFill>
-          <a:blip xmlns:r="http://schemas.openxmlformats.org/officeDocument/2006/relationships" xmlns:a="http://schemas.openxmlformats.org/drawingml/2006/main" r:embed="Reddd1fc4c4984f25"/>
+          <a:blip xmlns:r="http://schemas.openxmlformats.org/officeDocument/2006/relationships" xmlns:a="http://schemas.openxmlformats.org/drawingml/2006/main" r:embed="R440224cff31d445a"/>
           <a:stretch xmlns:a="http://schemas.openxmlformats.org/drawingml/2006/main">
             <a:fillRect l="0" t="0" r="0" b="0"/>
           </a:stretch>
@@ -15913,7 +15913,7 @@
           <p:nvPr/>
         </p:nvPicPr>
         <p:blipFill>
-          <a:blip xmlns:r="http://schemas.openxmlformats.org/officeDocument/2006/relationships" xmlns:a="http://schemas.openxmlformats.org/drawingml/2006/main" r:embed="Rf5bc748dcedf4fec"/>
+          <a:blip xmlns:r="http://schemas.openxmlformats.org/officeDocument/2006/relationships" xmlns:a="http://schemas.openxmlformats.org/drawingml/2006/main" r:embed="Rcfa43688998f47e4"/>
           <a:stretch xmlns:a="http://schemas.openxmlformats.org/drawingml/2006/main">
             <a:fillRect l="0" t="0" r="0" b="0"/>
           </a:stretch>
@@ -15990,7 +15990,7 @@
           <p:nvPr/>
         </p:nvPicPr>
         <p:blipFill>
-          <a:blip xmlns:r="http://schemas.openxmlformats.org/officeDocument/2006/relationships" xmlns:a="http://schemas.openxmlformats.org/drawingml/2006/main" r:embed="R721dd43b74f64cf5"/>
+          <a:blip xmlns:r="http://schemas.openxmlformats.org/officeDocument/2006/relationships" xmlns:a="http://schemas.openxmlformats.org/drawingml/2006/main" r:embed="R65248c52df6842e6"/>
           <a:stretch xmlns:a="http://schemas.openxmlformats.org/drawingml/2006/main">
             <a:fillRect l="0" t="0" r="0" b="0"/>
           </a:stretch>
@@ -16270,7 +16270,7 @@
           <p:nvPr/>
         </p:nvPicPr>
         <p:blipFill>
-          <a:blip xmlns:r="http://schemas.openxmlformats.org/officeDocument/2006/relationships" xmlns:a="http://schemas.openxmlformats.org/drawingml/2006/main" r:embed="R269c6f40d8ce4d3d"/>
+          <a:blip xmlns:r="http://schemas.openxmlformats.org/officeDocument/2006/relationships" xmlns:a="http://schemas.openxmlformats.org/drawingml/2006/main" r:embed="R3923b5a37e2b4e54"/>
           <a:stretch xmlns:a="http://schemas.openxmlformats.org/drawingml/2006/main">
             <a:fillRect l="0" t="0" r="0" b="0"/>
           </a:stretch>
@@ -16448,7 +16448,7 @@
           <p:nvPr/>
         </p:nvPicPr>
         <p:blipFill>
-          <a:blip xmlns:r="http://schemas.openxmlformats.org/officeDocument/2006/relationships" xmlns:a="http://schemas.openxmlformats.org/drawingml/2006/main" r:embed="R412a77ce2d6c4f8e"/>
+          <a:blip xmlns:r="http://schemas.openxmlformats.org/officeDocument/2006/relationships" xmlns:a="http://schemas.openxmlformats.org/drawingml/2006/main" r:embed="Rae0fe011a7b14ef3"/>
           <a:stretch xmlns:a="http://schemas.openxmlformats.org/drawingml/2006/main">
             <a:fillRect l="0" t="0" r="0" b="0"/>
           </a:stretch>
@@ -16472,7 +16472,7 @@
           <p:nvPr/>
         </p:nvPicPr>
         <p:blipFill>
-          <a:blip xmlns:r="http://schemas.openxmlformats.org/officeDocument/2006/relationships" xmlns:a="http://schemas.openxmlformats.org/drawingml/2006/main" r:embed="R6dca11ea966c4cd7"/>
+          <a:blip xmlns:r="http://schemas.openxmlformats.org/officeDocument/2006/relationships" xmlns:a="http://schemas.openxmlformats.org/drawingml/2006/main" r:embed="R5ccb44673d68480f"/>
           <a:stretch xmlns:a="http://schemas.openxmlformats.org/drawingml/2006/main">
             <a:fillRect l="0" t="0" r="0" b="0"/>
           </a:stretch>

</xml_diff>